<commit_message>
Restore pristine GrowwxIITB deck (byte-identical to original) to guarantee it opens
</commit_message>
<xml_diff>
--- a/AgriRover_GrowwxIITB.pptx
+++ b/AgriRover_GrowwxIITB.pptx
@@ -4,9 +4,6 @@
   <p:sldMasterIdLst>
     <p:sldMasterId id="2147483648" r:id="rId1"/>
   </p:sldMasterIdLst>
-  <p:notesMasterIdLst>
-    <p:notesMasterId r:id="rId28"/>
-  </p:notesMasterIdLst>
   <p:sldIdLst>
     <p:sldId id="256" r:id="rId7"/>
     <p:sldId id="257" r:id="rId8"/>
@@ -128,1050 +125,6 @@
     </a:lvl9pPr>
   </p:defaultTextStyle>
 </p:presentation>
-</file>
-
-<file path=ppt/notesMasters/notesMaster1.xml><?xml version="1.0" encoding="utf-8"?>
-<p:notesMaster xmlns:a="http://schemas.openxmlformats.org/drawingml/2006/main" xmlns:r="http://schemas.openxmlformats.org/officeDocument/2006/relationships" xmlns:p="http://schemas.openxmlformats.org/presentationml/2006/main">
-  <p:cSld>
-    <p:bg>
-      <p:bgRef idx="1001">
-        <a:schemeClr val="bg1"/>
-      </p:bgRef>
-    </p:bg>
-    <p:spTree>
-      <p:nvGrpSpPr>
-        <p:cNvPr id="1" name=""/>
-        <p:cNvGrpSpPr/>
-        <p:nvPr/>
-      </p:nvGrpSpPr>
-      <p:grpSpPr>
-        <a:xfrm>
-          <a:off x="0" y="0"/>
-          <a:ext cx="0" cy="0"/>
-          <a:chOff x="0" y="0"/>
-          <a:chExt cx="0" cy="0"/>
-        </a:xfrm>
-      </p:grpSpPr>
-      <p:sp>
-        <p:nvSpPr>
-          <p:cNvPr id="2" name="Notes Placeholder 1"/>
-          <p:cNvSpPr>
-            <a:spLocks noGrp="1"/>
-          </p:cNvSpPr>
-          <p:nvPr>
-            <p:ph type="body" idx="1"/>
-          </p:nvPr>
-        </p:nvSpPr>
-        <p:spPr>
-          <a:xfrm>
-            <a:off x="685800" y="4114800"/>
-            <a:ext cx="5486400" cy="3600450"/>
-          </a:xfrm>
-          <a:prstGeom prst="rect">
-            <a:avLst/>
-          </a:prstGeom>
-        </p:spPr>
-        <p:txBody>
-          <a:bodyPr vert="horz" lIns="91440" tIns="45720" rIns="91440" bIns="45720" rtlCol="0">
-            <a:normAutofit/>
-          </a:bodyPr>
-          <a:lstStyle/>
-          <a:p>
-            <a:endParaRPr lang="en-US"/>
-          </a:p>
-        </p:txBody>
-      </p:sp>
-    </p:spTree>
-  </p:cSld>
-  <p:clrMap bg1="lt1" tx1="dk1" bg2="lt2" tx2="dk2" accent1="accent1" accent2="accent2" accent3="accent3" accent4="accent4" accent5="accent5" accent6="accent6" hlink="hlink" folHlink="folHlink"/>
-</p:notesMaster>
-</file>
-
-<file path=ppt/notesSlides/notesSlide1.xml><?xml version="1.0" encoding="utf-8"?>
-<p:notes xmlns:a="http://schemas.openxmlformats.org/drawingml/2006/main" xmlns:r="http://schemas.openxmlformats.org/officeDocument/2006/relationships" xmlns:p="http://schemas.openxmlformats.org/presentationml/2006/main">
-  <p:cSld>
-    <p:spTree>
-      <p:nvGrpSpPr>
-        <p:cNvPr id="1" name=""/>
-        <p:cNvGrpSpPr/>
-        <p:nvPr/>
-      </p:nvGrpSpPr>
-      <p:grpSpPr>
-        <a:xfrm>
-          <a:off x="0" y="0"/>
-          <a:ext cx="0" cy="0"/>
-          <a:chOff x="0" y="0"/>
-          <a:chExt cx="0" cy="0"/>
-        </a:xfrm>
-      </p:grpSpPr>
-      <p:sp>
-        <p:nvSpPr>
-          <p:cNvPr id="2" name="Notes Placeholder 1"/>
-          <p:cNvSpPr>
-            <a:spLocks noGrp="1"/>
-          </p:cNvSpPr>
-          <p:nvPr>
-            <p:ph type="body" idx="1"/>
-          </p:nvPr>
-        </p:nvSpPr>
-        <p:spPr/>
-        <p:txBody>
-          <a:bodyPr/>
-          <a:lstStyle/>
-          <a:p>
-            <a:r>
-              <a:rPr lang="en-US" dirty="0"/>
-              <a:t>Good morning. We are AgriRover, a four-member team from IIT Bombay. Our one line: precision farming for every small farm. In the next few minutes I will walk you through the problem, our working prototype, the market and policy tailwinds, and exactly what we are asking for. (~15s)</a:t>
-            </a:r>
-          </a:p>
-        </p:txBody>
-      </p:sp>
-    </p:spTree>
-  </p:cSld>
-  <p:clrMapOvr>
-    <a:masterClrMapping/>
-  </p:clrMapOvr>
-</p:notes>
-</file>
-
-<file path=ppt/notesSlides/notesSlide10.xml><?xml version="1.0" encoding="utf-8"?>
-<p:notes xmlns:a="http://schemas.openxmlformats.org/drawingml/2006/main" xmlns:r="http://schemas.openxmlformats.org/officeDocument/2006/relationships" xmlns:p="http://schemas.openxmlformats.org/presentationml/2006/main">
-  <p:cSld>
-    <p:spTree>
-      <p:nvGrpSpPr>
-        <p:cNvPr id="1" name=""/>
-        <p:cNvGrpSpPr/>
-        <p:nvPr/>
-      </p:nvGrpSpPr>
-      <p:grpSpPr>
-        <a:xfrm>
-          <a:off x="0" y="0"/>
-          <a:ext cx="0" cy="0"/>
-          <a:chOff x="0" y="0"/>
-          <a:chExt cx="0" cy="0"/>
-        </a:xfrm>
-      </p:grpSpPr>
-      <p:sp>
-        <p:nvSpPr>
-          <p:cNvPr id="2" name="Notes Placeholder 1"/>
-          <p:cNvSpPr>
-            <a:spLocks noGrp="1"/>
-          </p:cNvSpPr>
-          <p:nvPr>
-            <p:ph type="body" idx="1"/>
-          </p:nvPr>
-        </p:nvSpPr>
-        <p:spPr/>
-        <p:txBody>
-          <a:bodyPr/>
-          <a:lstStyle/>
-          <a:p>
-            <a:r>
-              <a:rPr lang="en-US" dirty="0"/>
-              <a:t>Crucially, this is not just an idea. As a team we have already built the full firmware, the AI vision, the navigation stack, a live dashboard, a simulator, CI, a verified circuit and a 110-part costed bill of materials - all validated in simulation. Hardware integration is the next step. (~30s)</a:t>
-            </a:r>
-          </a:p>
-        </p:txBody>
-      </p:sp>
-    </p:spTree>
-  </p:cSld>
-  <p:clrMapOvr>
-    <a:masterClrMapping/>
-  </p:clrMapOvr>
-</p:notes>
-</file>
-
-<file path=ppt/notesSlides/notesSlide11.xml><?xml version="1.0" encoding="utf-8"?>
-<p:notes xmlns:a="http://schemas.openxmlformats.org/drawingml/2006/main" xmlns:r="http://schemas.openxmlformats.org/officeDocument/2006/relationships" xmlns:p="http://schemas.openxmlformats.org/presentationml/2006/main">
-  <p:cSld>
-    <p:spTree>
-      <p:nvGrpSpPr>
-        <p:cNvPr id="1" name=""/>
-        <p:cNvGrpSpPr/>
-        <p:nvPr/>
-      </p:nvGrpSpPr>
-      <p:grpSpPr>
-        <a:xfrm>
-          <a:off x="0" y="0"/>
-          <a:ext cx="0" cy="0"/>
-          <a:chOff x="0" y="0"/>
-          <a:chExt cx="0" cy="0"/>
-        </a:xfrm>
-      </p:grpSpPr>
-      <p:sp>
-        <p:nvSpPr>
-          <p:cNvPr id="2" name="Notes Placeholder 1"/>
-          <p:cNvSpPr>
-            <a:spLocks noGrp="1"/>
-          </p:cNvSpPr>
-          <p:nvPr>
-            <p:ph type="body" idx="1"/>
-          </p:nvPr>
-        </p:nvSpPr>
-        <p:spPr/>
-        <p:txBody>
-          <a:bodyPr/>
-          <a:lstStyle/>
-          <a:p>
-            <a:r>
-              <a:rPr lang="en-US" dirty="0"/>
-              <a:t>Our core hypothesis: per-plant sensing and targeted dosing cut fertiliser and chemical use sharply, with no yield loss. In the pilot we will measure input reduction, detection accuracy, and cost per acre. Targets to prove: 30 to 50 percent input reduction and over 85 percent detection accuracy. (~30s)</a:t>
-            </a:r>
-          </a:p>
-        </p:txBody>
-      </p:sp>
-    </p:spTree>
-  </p:cSld>
-  <p:clrMapOvr>
-    <a:masterClrMapping/>
-  </p:clrMapOvr>
-</p:notes>
-</file>
-
-<file path=ppt/notesSlides/notesSlide12.xml><?xml version="1.0" encoding="utf-8"?>
-<p:notes xmlns:a="http://schemas.openxmlformats.org/drawingml/2006/main" xmlns:r="http://schemas.openxmlformats.org/officeDocument/2006/relationships" xmlns:p="http://schemas.openxmlformats.org/presentationml/2006/main">
-  <p:cSld>
-    <p:spTree>
-      <p:nvGrpSpPr>
-        <p:cNvPr id="1" name=""/>
-        <p:cNvGrpSpPr/>
-        <p:nvPr/>
-      </p:nvGrpSpPr>
-      <p:grpSpPr>
-        <a:xfrm>
-          <a:off x="0" y="0"/>
-          <a:ext cx="0" cy="0"/>
-          <a:chOff x="0" y="0"/>
-          <a:chExt cx="0" cy="0"/>
-        </a:xfrm>
-      </p:grpSpPr>
-      <p:sp>
-        <p:nvSpPr>
-          <p:cNvPr id="2" name="Notes Placeholder 1"/>
-          <p:cNvSpPr>
-            <a:spLocks noGrp="1"/>
-          </p:cNvSpPr>
-          <p:nvPr>
-            <p:ph type="body" idx="1"/>
-          </p:nvPr>
-        </p:nvSpPr>
-        <p:spPr/>
-        <p:txBody>
-          <a:bodyPr/>
-          <a:lstStyle/>
-          <a:p>
-            <a:r>
-              <a:rPr lang="en-US" dirty="0"/>
-              <a:t>These are the numbers we are chasing, from our simulation and targets: about 45 percent less fertiliser, 40 percent cost saving per acre, and 88 percent detection accuracy - all to be validated in field pilots. Be clear with judges: these are projections, not yet field-measured. (~20s)</a:t>
-            </a:r>
-          </a:p>
-        </p:txBody>
-      </p:sp>
-    </p:spTree>
-  </p:cSld>
-  <p:clrMapOvr>
-    <a:masterClrMapping/>
-  </p:clrMapOvr>
-</p:notes>
-</file>
-
-<file path=ppt/notesSlides/notesSlide13.xml><?xml version="1.0" encoding="utf-8"?>
-<p:notes xmlns:a="http://schemas.openxmlformats.org/drawingml/2006/main" xmlns:r="http://schemas.openxmlformats.org/officeDocument/2006/relationships" xmlns:p="http://schemas.openxmlformats.org/presentationml/2006/main">
-  <p:cSld>
-    <p:spTree>
-      <p:nvGrpSpPr>
-        <p:cNvPr id="1" name=""/>
-        <p:cNvGrpSpPr/>
-        <p:nvPr/>
-      </p:nvGrpSpPr>
-      <p:grpSpPr>
-        <a:xfrm>
-          <a:off x="0" y="0"/>
-          <a:ext cx="0" cy="0"/>
-          <a:chOff x="0" y="0"/>
-          <a:chExt cx="0" cy="0"/>
-        </a:xfrm>
-      </p:grpSpPr>
-      <p:sp>
-        <p:nvSpPr>
-          <p:cNvPr id="2" name="Notes Placeholder 1"/>
-          <p:cNvSpPr>
-            <a:spLocks noGrp="1"/>
-          </p:cNvSpPr>
-          <p:nvPr>
-            <p:ph type="body" idx="1"/>
-          </p:nvPr>
-        </p:nvSpPr>
-        <p:spPr/>
-        <p:txBody>
-          <a:bodyPr/>
-          <a:lstStyle/>
-          <a:p>
-            <a:r>
-              <a:rPr lang="en-US" dirty="0"/>
-              <a:t>Execution is staged. Build the hardware prototype in about three months. Pilot on 5 to 10 farms, measuring savings, accuracy and uptime. Iterate and harden from field data - dust and 40-45 degree heat. Then scale through FPOs and CHCs with subsidy support, into Rover-as-a-Service. (~30s)</a:t>
-            </a:r>
-          </a:p>
-        </p:txBody>
-      </p:sp>
-    </p:spTree>
-  </p:cSld>
-  <p:clrMapOvr>
-    <a:masterClrMapping/>
-  </p:clrMapOvr>
-</p:notes>
-</file>
-
-<file path=ppt/notesSlides/notesSlide14.xml><?xml version="1.0" encoding="utf-8"?>
-<p:notes xmlns:a="http://schemas.openxmlformats.org/drawingml/2006/main" xmlns:r="http://schemas.openxmlformats.org/officeDocument/2006/relationships" xmlns:p="http://schemas.openxmlformats.org/presentationml/2006/main">
-  <p:cSld>
-    <p:spTree>
-      <p:nvGrpSpPr>
-        <p:cNvPr id="1" name=""/>
-        <p:cNvGrpSpPr/>
-        <p:nvPr/>
-      </p:nvGrpSpPr>
-      <p:grpSpPr>
-        <a:xfrm>
-          <a:off x="0" y="0"/>
-          <a:ext cx="0" cy="0"/>
-          <a:chOff x="0" y="0"/>
-          <a:chExt cx="0" cy="0"/>
-        </a:xfrm>
-      </p:grpSpPr>
-      <p:sp>
-        <p:nvSpPr>
-          <p:cNvPr id="2" name="Notes Placeholder 1"/>
-          <p:cNvSpPr>
-            <a:spLocks noGrp="1"/>
-          </p:cNvSpPr>
-          <p:nvPr>
-            <p:ph type="body" idx="1"/>
-          </p:nvPr>
-        </p:nvSpPr>
-        <p:spPr/>
-        <p:txBody>
-          <a:bodyPr/>
-          <a:lstStyle/>
-          <a:p>
-            <a:r>
-              <a:rPr lang="en-US" dirty="0"/>
-              <a:t>We are four IIT Bombay engineers - three mechanical, one aerospace - and we built this end-to-end. The impact is real: lower input cost, less fertiliser runoff, healthier soil and higher income - affordable precision farming for every smallholder. (~25s)</a:t>
-            </a:r>
-          </a:p>
-        </p:txBody>
-      </p:sp>
-    </p:spTree>
-  </p:cSld>
-  <p:clrMapOvr>
-    <a:masterClrMapping/>
-  </p:clrMapOvr>
-</p:notes>
-</file>
-
-<file path=ppt/notesSlides/notesSlide15.xml><?xml version="1.0" encoding="utf-8"?>
-<p:notes xmlns:a="http://schemas.openxmlformats.org/drawingml/2006/main" xmlns:r="http://schemas.openxmlformats.org/officeDocument/2006/relationships" xmlns:p="http://schemas.openxmlformats.org/presentationml/2006/main">
-  <p:cSld>
-    <p:spTree>
-      <p:nvGrpSpPr>
-        <p:cNvPr id="1" name=""/>
-        <p:cNvGrpSpPr/>
-        <p:nvPr/>
-      </p:nvGrpSpPr>
-      <p:grpSpPr>
-        <a:xfrm>
-          <a:off x="0" y="0"/>
-          <a:ext cx="0" cy="0"/>
-          <a:chOff x="0" y="0"/>
-          <a:chExt cx="0" cy="0"/>
-        </a:xfrm>
-      </p:grpSpPr>
-      <p:sp>
-        <p:nvSpPr>
-          <p:cNvPr id="2" name="Notes Placeholder 1"/>
-          <p:cNvSpPr>
-            <a:spLocks noGrp="1"/>
-          </p:cNvSpPr>
-          <p:nvPr>
-            <p:ph type="body" idx="1"/>
-          </p:nvPr>
-        </p:nvSpPr>
-        <p:spPr/>
-        <p:txBody>
-          <a:bodyPr/>
-          <a:lstStyle/>
-          <a:p>
-            <a:r>
-              <a:rPr lang="en-US" dirty="0"/>
-              <a:t>It is affordable and modular. A demo build is 8 to 14 thousand rupees; the full AI build is 27 to 48 thousand. All off-the-shelf parts, the software is free, and the printed parts are PETG. (~20s)</a:t>
-            </a:r>
-          </a:p>
-        </p:txBody>
-      </p:sp>
-    </p:spTree>
-  </p:cSld>
-  <p:clrMapOvr>
-    <a:masterClrMapping/>
-  </p:clrMapOvr>
-</p:notes>
-</file>
-
-<file path=ppt/notesSlides/notesSlide16.xml><?xml version="1.0" encoding="utf-8"?>
-<p:notes xmlns:a="http://schemas.openxmlformats.org/drawingml/2006/main" xmlns:r="http://schemas.openxmlformats.org/officeDocument/2006/relationships" xmlns:p="http://schemas.openxmlformats.org/presentationml/2006/main">
-  <p:cSld>
-    <p:spTree>
-      <p:nvGrpSpPr>
-        <p:cNvPr id="1" name=""/>
-        <p:cNvGrpSpPr/>
-        <p:nvPr/>
-      </p:nvGrpSpPr>
-      <p:grpSpPr>
-        <a:xfrm>
-          <a:off x="0" y="0"/>
-          <a:ext cx="0" cy="0"/>
-          <a:chOff x="0" y="0"/>
-          <a:chExt cx="0" cy="0"/>
-        </a:xfrm>
-      </p:grpSpPr>
-      <p:sp>
-        <p:nvSpPr>
-          <p:cNvPr id="2" name="Notes Placeholder 1"/>
-          <p:cNvSpPr>
-            <a:spLocks noGrp="1"/>
-          </p:cNvSpPr>
-          <p:nvPr>
-            <p:ph type="body" idx="1"/>
-          </p:nvPr>
-        </p:nvSpPr>
-        <p:spPr/>
-        <p:txBody>
-          <a:bodyPr/>
-          <a:lstStyle/>
-          <a:p>
-            <a:r>
-              <a:rPr lang="en-US" dirty="0"/>
-              <a:t>So our ask: mentorship and a pilot - field access through an FPO or Custom Hiring Centre - and seed support to build the prototype and run the first pilots. Thank you - precision farming, for every small farm. We are happy to take questions. (~20s)</a:t>
-            </a:r>
-          </a:p>
-        </p:txBody>
-      </p:sp>
-    </p:spTree>
-  </p:cSld>
-  <p:clrMapOvr>
-    <a:masterClrMapping/>
-  </p:clrMapOvr>
-</p:notes>
-</file>
-
-<file path=ppt/notesSlides/notesSlide17.xml><?xml version="1.0" encoding="utf-8"?>
-<p:notes xmlns:a="http://schemas.openxmlformats.org/drawingml/2006/main" xmlns:r="http://schemas.openxmlformats.org/officeDocument/2006/relationships" xmlns:p="http://schemas.openxmlformats.org/presentationml/2006/main">
-  <p:cSld>
-    <p:spTree>
-      <p:nvGrpSpPr>
-        <p:cNvPr id="1" name=""/>
-        <p:cNvGrpSpPr/>
-        <p:nvPr/>
-      </p:nvGrpSpPr>
-      <p:grpSpPr>
-        <a:xfrm>
-          <a:off x="0" y="0"/>
-          <a:ext cx="0" cy="0"/>
-          <a:chOff x="0" y="0"/>
-          <a:chExt cx="0" cy="0"/>
-        </a:xfrm>
-      </p:grpSpPr>
-      <p:sp>
-        <p:nvSpPr>
-          <p:cNvPr id="2" name="Notes Placeholder 1"/>
-          <p:cNvSpPr>
-            <a:spLocks noGrp="1"/>
-          </p:cNvSpPr>
-          <p:nvPr>
-            <p:ph type="body" idx="1"/>
-          </p:nvPr>
-        </p:nvSpPr>
-        <p:spPr/>
-        <p:txBody>
-          <a:bodyPr/>
-          <a:lstStyle/>
-          <a:p>
-            <a:r>
-              <a:rPr lang="en-US" dirty="0"/>
-              <a:t>These appendix slides are our engineering depth, if you would like to dig in during questions - electronics, the drive system, the mechanical layout, and the ten field risks we have engineered.</a:t>
-            </a:r>
-          </a:p>
-        </p:txBody>
-      </p:sp>
-    </p:spTree>
-  </p:cSld>
-  <p:clrMapOvr>
-    <a:masterClrMapping/>
-  </p:clrMapOvr>
-</p:notes>
-</file>
-
-<file path=ppt/notesSlides/notesSlide18.xml><?xml version="1.0" encoding="utf-8"?>
-<p:notes xmlns:a="http://schemas.openxmlformats.org/drawingml/2006/main" xmlns:r="http://schemas.openxmlformats.org/officeDocument/2006/relationships" xmlns:p="http://schemas.openxmlformats.org/presentationml/2006/main">
-  <p:cSld>
-    <p:spTree>
-      <p:nvGrpSpPr>
-        <p:cNvPr id="1" name=""/>
-        <p:cNvGrpSpPr/>
-        <p:nvPr/>
-      </p:nvGrpSpPr>
-      <p:grpSpPr>
-        <a:xfrm>
-          <a:off x="0" y="0"/>
-          <a:ext cx="0" cy="0"/>
-          <a:chOff x="0" y="0"/>
-          <a:chExt cx="0" cy="0"/>
-        </a:xfrm>
-      </p:grpSpPr>
-      <p:sp>
-        <p:nvSpPr>
-          <p:cNvPr id="2" name="Notes Placeholder 1"/>
-          <p:cNvSpPr>
-            <a:spLocks noGrp="1"/>
-          </p:cNvSpPr>
-          <p:nvPr>
-            <p:ph type="body" idx="1"/>
-          </p:nvPr>
-        </p:nvSpPr>
-        <p:spPr/>
-        <p:txBody>
-          <a:bodyPr/>
-          <a:lstStyle/>
-          <a:p>
-            <a:r>
-              <a:rPr lang="en-US" dirty="0"/>
-              <a:t>Our electronics: 110 BOM components plus 15 gap-audit items - every bus, divider and safety part placed. This is the consolidated v2 wiring; the red paths are safety-critical.</a:t>
-            </a:r>
-          </a:p>
-        </p:txBody>
-      </p:sp>
-    </p:spTree>
-  </p:cSld>
-  <p:clrMapOvr>
-    <a:masterClrMapping/>
-  </p:clrMapOvr>
-</p:notes>
-</file>
-
-<file path=ppt/notesSlides/notesSlide19.xml><?xml version="1.0" encoding="utf-8"?>
-<p:notes xmlns:a="http://schemas.openxmlformats.org/drawingml/2006/main" xmlns:r="http://schemas.openxmlformats.org/officeDocument/2006/relationships" xmlns:p="http://schemas.openxmlformats.org/presentationml/2006/main">
-  <p:cSld>
-    <p:spTree>
-      <p:nvGrpSpPr>
-        <p:cNvPr id="1" name=""/>
-        <p:cNvGrpSpPr/>
-        <p:nvPr/>
-      </p:nvGrpSpPr>
-      <p:grpSpPr>
-        <a:xfrm>
-          <a:off x="0" y="0"/>
-          <a:ext cx="0" cy="0"/>
-          <a:chOff x="0" y="0"/>
-          <a:chExt cx="0" cy="0"/>
-        </a:xfrm>
-      </p:grpSpPr>
-      <p:sp>
-        <p:nvSpPr>
-          <p:cNvPr id="2" name="Notes Placeholder 1"/>
-          <p:cNvSpPr>
-            <a:spLocks noGrp="1"/>
-          </p:cNvSpPr>
-          <p:nvPr>
-            <p:ph type="body" idx="1"/>
-          </p:nvPr>
-        </p:nvSpPr>
-        <p:spPr/>
-        <p:txBody>
-          <a:bodyPr/>
-          <a:lstStyle/>
-          <a:p>
-            <a:r>
-              <a:rPr lang="en-US" dirty="0"/>
-              <a:t>The drive system: we replaced the under-spec L298N with two BTS7960 MOSFET drivers - about 43 amps per side, dual-PWM for forward, reverse and coast, flyback protection, and current-sense for stall detection.</a:t>
-            </a:r>
-          </a:p>
-        </p:txBody>
-      </p:sp>
-    </p:spTree>
-  </p:cSld>
-  <p:clrMapOvr>
-    <a:masterClrMapping/>
-  </p:clrMapOvr>
-</p:notes>
-</file>
-
-<file path=ppt/notesSlides/notesSlide2.xml><?xml version="1.0" encoding="utf-8"?>
-<p:notes xmlns:a="http://schemas.openxmlformats.org/drawingml/2006/main" xmlns:r="http://schemas.openxmlformats.org/officeDocument/2006/relationships" xmlns:p="http://schemas.openxmlformats.org/presentationml/2006/main">
-  <p:cSld>
-    <p:spTree>
-      <p:nvGrpSpPr>
-        <p:cNvPr id="1" name=""/>
-        <p:cNvGrpSpPr/>
-        <p:nvPr/>
-      </p:nvGrpSpPr>
-      <p:grpSpPr>
-        <a:xfrm>
-          <a:off x="0" y="0"/>
-          <a:ext cx="0" cy="0"/>
-          <a:chOff x="0" y="0"/>
-          <a:chExt cx="0" cy="0"/>
-        </a:xfrm>
-      </p:grpSpPr>
-      <p:sp>
-        <p:nvSpPr>
-          <p:cNvPr id="2" name="Notes Placeholder 1"/>
-          <p:cNvSpPr>
-            <a:spLocks noGrp="1"/>
-          </p:cNvSpPr>
-          <p:nvPr>
-            <p:ph type="body" idx="1"/>
-          </p:nvPr>
-        </p:nvSpPr>
-        <p:spPr/>
-        <p:txBody>
-          <a:bodyPr/>
-          <a:lstStyle/>
-          <a:p>
-            <a:r>
-              <a:rPr lang="en-US" dirty="0"/>
-              <a:t>India's farms are tiny - 86% are under 2 hectares, too small for tractors. So farmers fertilise by guesswork, over-apply urea, waste money and degrade the soil. Soil-health cards exist, but lab tests take 2-3 weeks, so old habits win. We validated this ourselves: talking to local farmers and input dealers, blind hand-broadcasting is the norm. (~40s)</a:t>
-            </a:r>
-          </a:p>
-        </p:txBody>
-      </p:sp>
-    </p:spTree>
-  </p:cSld>
-  <p:clrMapOvr>
-    <a:masterClrMapping/>
-  </p:clrMapOvr>
-</p:notes>
-</file>
-
-<file path=ppt/notesSlides/notesSlide20.xml><?xml version="1.0" encoding="utf-8"?>
-<p:notes xmlns:a="http://schemas.openxmlformats.org/drawingml/2006/main" xmlns:r="http://schemas.openxmlformats.org/officeDocument/2006/relationships" xmlns:p="http://schemas.openxmlformats.org/presentationml/2006/main">
-  <p:cSld>
-    <p:spTree>
-      <p:nvGrpSpPr>
-        <p:cNvPr id="1" name=""/>
-        <p:cNvGrpSpPr/>
-        <p:nvPr/>
-      </p:nvGrpSpPr>
-      <p:grpSpPr>
-        <a:xfrm>
-          <a:off x="0" y="0"/>
-          <a:ext cx="0" cy="0"/>
-          <a:chOff x="0" y="0"/>
-          <a:chExt cx="0" cy="0"/>
-        </a:xfrm>
-      </p:grpSpPr>
-      <p:sp>
-        <p:nvSpPr>
-          <p:cNvPr id="2" name="Notes Placeholder 1"/>
-          <p:cNvSpPr>
-            <a:spLocks noGrp="1"/>
-          </p:cNvSpPr>
-          <p:nvPr>
-            <p:ph type="body" idx="1"/>
-          </p:nvPr>
-        </p:nvSpPr>
-        <p:spPr/>
-        <p:txBody>
-          <a:bodyPr/>
-          <a:lstStyle/>
-          <a:p>
-            <a:r>
-              <a:rPr lang="en-US" dirty="0"/>
-              <a:t>The mechanical layout, drawn to scale from verified coordinates: a double-decker 320 by 450 mm chassis. Low centre of gravity with battery and tank kept low, fluids below the electronics, and the heat-generating drivers at the rear by the fan.</a:t>
-            </a:r>
-          </a:p>
-        </p:txBody>
-      </p:sp>
-    </p:spTree>
-  </p:cSld>
-  <p:clrMapOvr>
-    <a:masterClrMapping/>
-  </p:clrMapOvr>
-</p:notes>
-</file>
-
-<file path=ppt/notesSlides/notesSlide21.xml><?xml version="1.0" encoding="utf-8"?>
-<p:notes xmlns:a="http://schemas.openxmlformats.org/drawingml/2006/main" xmlns:r="http://schemas.openxmlformats.org/officeDocument/2006/relationships" xmlns:p="http://schemas.openxmlformats.org/presentationml/2006/main">
-  <p:cSld>
-    <p:spTree>
-      <p:nvGrpSpPr>
-        <p:cNvPr id="1" name=""/>
-        <p:cNvGrpSpPr/>
-        <p:nvPr/>
-      </p:nvGrpSpPr>
-      <p:grpSpPr>
-        <a:xfrm>
-          <a:off x="0" y="0"/>
-          <a:ext cx="0" cy="0"/>
-          <a:chOff x="0" y="0"/>
-          <a:chExt cx="0" cy="0"/>
-        </a:xfrm>
-      </p:grpSpPr>
-      <p:sp>
-        <p:nvSpPr>
-          <p:cNvPr id="2" name="Notes Placeholder 1"/>
-          <p:cNvSpPr>
-            <a:spLocks noGrp="1"/>
-          </p:cNvSpPr>
-          <p:nvPr>
-            <p:ph type="body" idx="1"/>
-          </p:nvPr>
-        </p:nvSpPr>
-        <p:spPr/>
-        <p:txBody>
-          <a:bodyPr/>
-          <a:lstStyle/>
-          <a:p>
-            <a:r>
-              <a:rPr lang="en-US" dirty="0"/>
-              <a:t>Finally, ten real field risks we have already engineered - from weeds above the pathway and field-heat battery safety, to comms-loss dead-man halt and dust sealing. Most are implemented in code; the rest are code-ready.</a:t>
-            </a:r>
-          </a:p>
-        </p:txBody>
-      </p:sp>
-    </p:spTree>
-  </p:cSld>
-  <p:clrMapOvr>
-    <a:masterClrMapping/>
-  </p:clrMapOvr>
-</p:notes>
-</file>
-
-<file path=ppt/notesSlides/notesSlide3.xml><?xml version="1.0" encoding="utf-8"?>
-<p:notes xmlns:a="http://schemas.openxmlformats.org/drawingml/2006/main" xmlns:r="http://schemas.openxmlformats.org/officeDocument/2006/relationships" xmlns:p="http://schemas.openxmlformats.org/presentationml/2006/main">
-  <p:cSld>
-    <p:spTree>
-      <p:nvGrpSpPr>
-        <p:cNvPr id="1" name=""/>
-        <p:cNvGrpSpPr/>
-        <p:nvPr/>
-      </p:nvGrpSpPr>
-      <p:grpSpPr>
-        <a:xfrm>
-          <a:off x="0" y="0"/>
-          <a:ext cx="0" cy="0"/>
-          <a:chOff x="0" y="0"/>
-          <a:chExt cx="0" cy="0"/>
-        </a:xfrm>
-      </p:grpSpPr>
-      <p:sp>
-        <p:nvSpPr>
-          <p:cNvPr id="2" name="Notes Placeholder 1"/>
-          <p:cNvSpPr>
-            <a:spLocks noGrp="1"/>
-          </p:cNvSpPr>
-          <p:nvPr>
-            <p:ph type="body" idx="1"/>
-          </p:nvPr>
-        </p:nvSpPr>
-        <p:spPr/>
-        <p:txBody>
-          <a:bodyPr/>
-          <a:lstStyle/>
-          <a:p>
-            <a:r>
-              <a:rPr lang="en-US" dirty="0"/>
-              <a:t>Our answer is one low-cost autonomous rover that senses, decides and acts per plant. It reads soil NPK, uses AI vision to spot weeds and disease, then micro-doses fertiliser and spot-sprays exactly where needed - and logs everything for next season. Precision farming at a fraction of big-machinery cost. (~35s)</a:t>
-            </a:r>
-          </a:p>
-        </p:txBody>
-      </p:sp>
-    </p:spTree>
-  </p:cSld>
-  <p:clrMapOvr>
-    <a:masterClrMapping/>
-  </p:clrMapOvr>
-</p:notes>
-</file>
-
-<file path=ppt/notesSlides/notesSlide4.xml><?xml version="1.0" encoding="utf-8"?>
-<p:notes xmlns:a="http://schemas.openxmlformats.org/drawingml/2006/main" xmlns:r="http://schemas.openxmlformats.org/officeDocument/2006/relationships" xmlns:p="http://schemas.openxmlformats.org/presentationml/2006/main">
-  <p:cSld>
-    <p:spTree>
-      <p:nvGrpSpPr>
-        <p:cNvPr id="1" name=""/>
-        <p:cNvGrpSpPr/>
-        <p:nvPr/>
-      </p:nvGrpSpPr>
-      <p:grpSpPr>
-        <a:xfrm>
-          <a:off x="0" y="0"/>
-          <a:ext cx="0" cy="0"/>
-          <a:chOff x="0" y="0"/>
-          <a:chExt cx="0" cy="0"/>
-        </a:xfrm>
-      </p:grpSpPr>
-      <p:sp>
-        <p:nvSpPr>
-          <p:cNvPr id="2" name="Notes Placeholder 1"/>
-          <p:cNvSpPr>
-            <a:spLocks noGrp="1"/>
-          </p:cNvSpPr>
-          <p:nvPr>
-            <p:ph type="body" idx="1"/>
-          </p:nvPr>
-        </p:nvSpPr>
-        <p:spPr/>
-        <p:txBody>
-          <a:bodyPr/>
-          <a:lstStyle/>
-          <a:p>
-            <a:r>
-              <a:rPr lang="en-US" dirty="0"/>
-              <a:t>Why us and not the alternatives? Tractors are powerful but far too big and costly for small farms. Drones spray but cannot sense soil or act per plant. Manual labour is cheap per use but recurring. AgriRover is the only option that is affordable, autonomous and per-plant - and it also senses the soil. (~30s)</a:t>
-            </a:r>
-          </a:p>
-        </p:txBody>
-      </p:sp>
-    </p:spTree>
-  </p:cSld>
-  <p:clrMapOvr>
-    <a:masterClrMapping/>
-  </p:clrMapOvr>
-</p:notes>
-</file>
-
-<file path=ppt/notesSlides/notesSlide5.xml><?xml version="1.0" encoding="utf-8"?>
-<p:notes xmlns:a="http://schemas.openxmlformats.org/drawingml/2006/main" xmlns:r="http://schemas.openxmlformats.org/officeDocument/2006/relationships" xmlns:p="http://schemas.openxmlformats.org/presentationml/2006/main">
-  <p:cSld>
-    <p:spTree>
-      <p:nvGrpSpPr>
-        <p:cNvPr id="1" name=""/>
-        <p:cNvGrpSpPr/>
-        <p:nvPr/>
-      </p:nvGrpSpPr>
-      <p:grpSpPr>
-        <a:xfrm>
-          <a:off x="0" y="0"/>
-          <a:ext cx="0" cy="0"/>
-          <a:chOff x="0" y="0"/>
-          <a:chExt cx="0" cy="0"/>
-        </a:xfrm>
-      </p:grpSpPr>
-      <p:sp>
-        <p:nvSpPr>
-          <p:cNvPr id="2" name="Notes Placeholder 1"/>
-          <p:cNvSpPr>
-            <a:spLocks noGrp="1"/>
-          </p:cNvSpPr>
-          <p:nvPr>
-            <p:ph type="body" idx="1"/>
-          </p:nvPr>
-        </p:nvSpPr>
-        <p:spPr/>
-        <p:txBody>
-          <a:bodyPr/>
-          <a:lstStyle/>
-          <a:p>
-            <a:r>
-              <a:rPr lang="en-US" dirty="0"/>
-              <a:t>Under the hood, two brains. A real-time ESP32 running FreeRTOS handles drive, sensing and dosing. A Raspberry Pi 4 runs the AI vision and analytics. They talk over an HMAC-signed link, so safety-critical control stays real-time while the AI stays flexible. (~25s)</a:t>
-            </a:r>
-          </a:p>
-        </p:txBody>
-      </p:sp>
-    </p:spTree>
-  </p:cSld>
-  <p:clrMapOvr>
-    <a:masterClrMapping/>
-  </p:clrMapOvr>
-</p:notes>
-</file>
-
-<file path=ppt/notesSlides/notesSlide6.xml><?xml version="1.0" encoding="utf-8"?>
-<p:notes xmlns:a="http://schemas.openxmlformats.org/drawingml/2006/main" xmlns:r="http://schemas.openxmlformats.org/officeDocument/2006/relationships" xmlns:p="http://schemas.openxmlformats.org/presentationml/2006/main">
-  <p:cSld>
-    <p:spTree>
-      <p:nvGrpSpPr>
-        <p:cNvPr id="1" name=""/>
-        <p:cNvGrpSpPr/>
-        <p:nvPr/>
-      </p:nvGrpSpPr>
-      <p:grpSpPr>
-        <a:xfrm>
-          <a:off x="0" y="0"/>
-          <a:ext cx="0" cy="0"/>
-          <a:chOff x="0" y="0"/>
-          <a:chExt cx="0" cy="0"/>
-        </a:xfrm>
-      </p:grpSpPr>
-      <p:sp>
-        <p:nvSpPr>
-          <p:cNvPr id="2" name="Notes Placeholder 1"/>
-          <p:cNvSpPr>
-            <a:spLocks noGrp="1"/>
-          </p:cNvSpPr>
-          <p:nvPr>
-            <p:ph type="body" idx="1"/>
-          </p:nvPr>
-        </p:nvSpPr>
-        <p:spPr/>
-        <p:txBody>
-          <a:bodyPr/>
-          <a:lstStyle/>
-          <a:p>
-            <a:r>
-              <a:rPr lang="en-US" dirty="0"/>
-              <a:t>On sensing: a 7-in-1 industrial probe reads N, P, K, pH, EC, moisture and temperature over RS485 Modbus, calibrated and oversampled for reliability. On vision: three models - obstacle, weed and disease - run on a Coral Edge TPU at around 30 frames per second, roughly 10x faster than CPU, and it fails safe if a model is missing. (~35s)</a:t>
-            </a:r>
-          </a:p>
-        </p:txBody>
-      </p:sp>
-    </p:spTree>
-  </p:cSld>
-  <p:clrMapOvr>
-    <a:masterClrMapping/>
-  </p:clrMapOvr>
-</p:notes>
-</file>
-
-<file path=ppt/notesSlides/notesSlide7.xml><?xml version="1.0" encoding="utf-8"?>
-<p:notes xmlns:a="http://schemas.openxmlformats.org/drawingml/2006/main" xmlns:r="http://schemas.openxmlformats.org/officeDocument/2006/relationships" xmlns:p="http://schemas.openxmlformats.org/presentationml/2006/main">
-  <p:cSld>
-    <p:spTree>
-      <p:nvGrpSpPr>
-        <p:cNvPr id="1" name=""/>
-        <p:cNvGrpSpPr/>
-        <p:nvPr/>
-      </p:nvGrpSpPr>
-      <p:grpSpPr>
-        <a:xfrm>
-          <a:off x="0" y="0"/>
-          <a:ext cx="0" cy="0"/>
-          <a:chOff x="0" y="0"/>
-          <a:chExt cx="0" cy="0"/>
-        </a:xfrm>
-      </p:grpSpPr>
-      <p:sp>
-        <p:nvSpPr>
-          <p:cNvPr id="2" name="Notes Placeholder 1"/>
-          <p:cNvSpPr>
-            <a:spLocks noGrp="1"/>
-          </p:cNvSpPr>
-          <p:nvPr>
-            <p:ph type="body" idx="1"/>
-          </p:nvPr>
-        </p:nvSpPr>
-        <p:spPr/>
-        <p:txBody>
-          <a:bodyPr/>
-          <a:lstStyle/>
-          <a:p>
-            <a:r>
-              <a:rPr lang="en-US" dirty="0"/>
-              <a:t>Action and autonomy: dosing is sequential - pre-soak, probe, dose, retract - and the drive is frozen while dosing. A pan-tilt nozzle aims spray at each detected weed. It drives autonomous snake routes using GPS, SBAS and EKF fusion, with closed-loop velocity control for straight rows. And it is fail-safe by design: E-stop, dead-man heartbeat, thermal guardian and stall stop. (~40s)</a:t>
-            </a:r>
-          </a:p>
-        </p:txBody>
-      </p:sp>
-    </p:spTree>
-  </p:cSld>
-  <p:clrMapOvr>
-    <a:masterClrMapping/>
-  </p:clrMapOvr>
-</p:notes>
-</file>
-
-<file path=ppt/notesSlides/notesSlide8.xml><?xml version="1.0" encoding="utf-8"?>
-<p:notes xmlns:a="http://schemas.openxmlformats.org/drawingml/2006/main" xmlns:r="http://schemas.openxmlformats.org/officeDocument/2006/relationships" xmlns:p="http://schemas.openxmlformats.org/presentationml/2006/main">
-  <p:cSld>
-    <p:spTree>
-      <p:nvGrpSpPr>
-        <p:cNvPr id="1" name=""/>
-        <p:cNvGrpSpPr/>
-        <p:nvPr/>
-      </p:nvGrpSpPr>
-      <p:grpSpPr>
-        <a:xfrm>
-          <a:off x="0" y="0"/>
-          <a:ext cx="0" cy="0"/>
-          <a:chOff x="0" y="0"/>
-          <a:chExt cx="0" cy="0"/>
-        </a:xfrm>
-      </p:grpSpPr>
-      <p:sp>
-        <p:nvSpPr>
-          <p:cNvPr id="2" name="Notes Placeholder 1"/>
-          <p:cNvSpPr>
-            <a:spLocks noGrp="1"/>
-          </p:cNvSpPr>
-          <p:nvPr>
-            <p:ph type="body" idx="1"/>
-          </p:nvPr>
-        </p:nvSpPr>
-        <p:spPr/>
-        <p:txBody>
-          <a:bodyPr/>
-          <a:lstStyle/>
-          <a:p>
-            <a:r>
-              <a:rPr lang="en-US" dirty="0"/>
-              <a:t>The market is large and growing. India's precision-agriculture market roughly doubles to about 739 million dollars by 2034; broader agritech hits 2.5 billion. Our core is the 126 million small and marginal farms. We grow across crops and geographies, and into recurring data services. (~30s)</a:t>
-            </a:r>
-          </a:p>
-        </p:txBody>
-      </p:sp>
-    </p:spTree>
-  </p:cSld>
-  <p:clrMapOvr>
-    <a:masterClrMapping/>
-  </p:clrMapOvr>
-</p:notes>
-</file>
-
-<file path=ppt/notesSlides/notesSlide9.xml><?xml version="1.0" encoding="utf-8"?>
-<p:notes xmlns:a="http://schemas.openxmlformats.org/drawingml/2006/main" xmlns:r="http://schemas.openxmlformats.org/officeDocument/2006/relationships" xmlns:p="http://schemas.openxmlformats.org/presentationml/2006/main">
-  <p:cSld>
-    <p:spTree>
-      <p:nvGrpSpPr>
-        <p:cNvPr id="1" name=""/>
-        <p:cNvGrpSpPr/>
-        <p:nvPr/>
-      </p:nvGrpSpPr>
-      <p:grpSpPr>
-        <a:xfrm>
-          <a:off x="0" y="0"/>
-          <a:ext cx="0" cy="0"/>
-          <a:chOff x="0" y="0"/>
-          <a:chExt cx="0" cy="0"/>
-        </a:xfrm>
-      </p:grpSpPr>
-      <p:sp>
-        <p:nvSpPr>
-          <p:cNvPr id="2" name="Notes Placeholder 1"/>
-          <p:cNvSpPr>
-            <a:spLocks noGrp="1"/>
-          </p:cNvSpPr>
-          <p:nvPr>
-            <p:ph type="body" idx="1"/>
-          </p:nvPr>
-        </p:nvSpPr>
-        <p:spPr/>
-        <p:txBody>
-          <a:bodyPr/>
-          <a:lstStyle/>
-          <a:p>
-            <a:r>
-              <a:rPr lang="en-US" dirty="0"/>
-              <a:t>And policy is firmly on our side. SMAM gives 50 to 80 percent subsidy on machinery and funds Custom Hiring Centres; the Agri Infrastructure Fund finances FPOs; the Soil Health Card mission aligns with our sensing. We go to market through FPOs and CHCs - rover sale, Rover-as-a-Service per acre, plus a data subscription. (~35s)</a:t>
-            </a:r>
-          </a:p>
-        </p:txBody>
-      </p:sp>
-    </p:spTree>
-  </p:cSld>
-  <p:clrMapOvr>
-    <a:masterClrMapping/>
-  </p:clrMapOvr>
-</p:notes>
 </file>
 
 <file path=ppt/slideLayouts/slideLayout1.xml><?xml version="1.0" encoding="utf-8"?>

</xml_diff>

<commit_message>
Refine premium deck: remove bullet dots (clean self-explanatory lines), checkmark traction icons, sharper hypothesis
</commit_message>
<xml_diff>
--- a/AgriRover_GrowwxIITB.pptx
+++ b/AgriRover_GrowwxIITB.pptx
@@ -794,7 +794,7 @@
                 </a:solidFill>
                 <a:latin typeface="Calibri"/>
               </a:rPr>
-              <a:t>Hypothesis:  </a:t>
+              <a:t>Our hypothesis   </a:t>
             </a:r>
             <a:r>
               <a:rPr lang="en-US" sz="1300" dirty="0">
@@ -803,7 +803,7 @@
                 </a:solidFill>
                 <a:latin typeface="Calibri"/>
               </a:rPr>
-              <a:t>per-plant sensing + targeted dosing cuts fertiliser/chemical use sharply — with no yield loss.</a:t>
+              <a:t>— per-plant sensing + targeted dosing cut fertiliser &amp; pesticide use 30–50%, with no yield loss.</a:t>
             </a:r>
           </a:p>
         </p:txBody>
@@ -941,15 +941,14 @@
           </a:bodyPr>
           <a:lstStyle/>
           <a:p>
-            <a:pPr marL="201168" indent="-201168" algn="l">
+            <a:pPr marL="18288" indent="0" algn="l">
               <a:spcBef>
                 <a:spcPts val="0"/>
               </a:spcBef>
               <a:spcAft>
                 <a:spcPts val="140"/>
               </a:spcAft>
-              <a:buFont typeface="Arial"/>
-              <a:buChar char="•"/>
+              <a:buNone/>
             </a:pPr>
             <a:r>
               <a:rPr lang="en-US" sz="1050" dirty="0">
@@ -1096,15 +1095,14 @@
           </a:bodyPr>
           <a:lstStyle/>
           <a:p>
-            <a:pPr marL="201168" indent="-201168" algn="l">
+            <a:pPr marL="18288" indent="0" algn="l">
               <a:spcBef>
                 <a:spcPts val="0"/>
               </a:spcBef>
               <a:spcAft>
                 <a:spcPts val="140"/>
               </a:spcAft>
-              <a:buFont typeface="Arial"/>
-              <a:buChar char="•"/>
+              <a:buNone/>
             </a:pPr>
             <a:r>
               <a:rPr lang="en-US" sz="1050" dirty="0">
@@ -1251,15 +1249,14 @@
           </a:bodyPr>
           <a:lstStyle/>
           <a:p>
-            <a:pPr marL="201168" indent="-201168" algn="l">
+            <a:pPr marL="18288" indent="0" algn="l">
               <a:spcBef>
                 <a:spcPts val="0"/>
               </a:spcBef>
               <a:spcAft>
                 <a:spcPts val="140"/>
               </a:spcAft>
-              <a:buFont typeface="Arial"/>
-              <a:buChar char="•"/>
+              <a:buNone/>
             </a:pPr>
             <a:r>
               <a:rPr lang="en-US" sz="1050" dirty="0">
@@ -4638,15 +4635,14 @@
           </a:bodyPr>
           <a:lstStyle/>
           <a:p>
-            <a:pPr marL="201168" indent="-201168" algn="l">
+            <a:pPr marL="18288" indent="0" algn="l">
               <a:spcBef>
                 <a:spcPts val="0"/>
               </a:spcBef>
               <a:spcAft>
                 <a:spcPts val="140"/>
               </a:spcAft>
-              <a:buFont typeface="Arial"/>
-              <a:buChar char="•"/>
+              <a:buNone/>
             </a:pPr>
             <a:r>
               <a:rPr lang="en-US" sz="1050" dirty="0">
@@ -4937,15 +4933,14 @@
           </a:bodyPr>
           <a:lstStyle/>
           <a:p>
-            <a:pPr marL="201168" indent="-201168" algn="l">
+            <a:pPr marL="18288" indent="0" algn="l">
               <a:spcBef>
                 <a:spcPts val="0"/>
               </a:spcBef>
               <a:spcAft>
                 <a:spcPts val="140"/>
               </a:spcAft>
-              <a:buFont typeface="Arial"/>
-              <a:buChar char="•"/>
+              <a:buNone/>
             </a:pPr>
             <a:r>
               <a:rPr lang="en-US" sz="1050" dirty="0">
@@ -5236,15 +5231,14 @@
           </a:bodyPr>
           <a:lstStyle/>
           <a:p>
-            <a:pPr marL="201168" indent="-201168" algn="l">
+            <a:pPr marL="18288" indent="0" algn="l">
               <a:spcBef>
                 <a:spcPts val="0"/>
               </a:spcBef>
               <a:spcAft>
                 <a:spcPts val="140"/>
               </a:spcAft>
-              <a:buFont typeface="Arial"/>
-              <a:buChar char="•"/>
+              <a:buNone/>
             </a:pPr>
             <a:r>
               <a:rPr lang="en-US" sz="1050" dirty="0">
@@ -5535,15 +5529,14 @@
           </a:bodyPr>
           <a:lstStyle/>
           <a:p>
-            <a:pPr marL="201168" indent="-201168" algn="l">
+            <a:pPr marL="18288" indent="0" algn="l">
               <a:spcBef>
                 <a:spcPts val="0"/>
               </a:spcBef>
               <a:spcAft>
                 <a:spcPts val="140"/>
               </a:spcAft>
-              <a:buFont typeface="Arial"/>
-              <a:buChar char="•"/>
+              <a:buNone/>
             </a:pPr>
             <a:r>
               <a:rPr lang="en-US" sz="1050" dirty="0">
@@ -8317,15 +8310,14 @@
             </a:r>
           </a:p>
           <a:p>
-            <a:pPr marL="219456" indent="-219456" algn="l">
+            <a:pPr marL="18288" indent="0" algn="l">
               <a:spcBef>
                 <a:spcPts val="0"/>
               </a:spcBef>
               <a:spcAft>
                 <a:spcPts val="160"/>
               </a:spcAft>
-              <a:buFont typeface="Arial"/>
-              <a:buChar char="•"/>
+              <a:buNone/>
             </a:pPr>
             <a:r>
               <a:rPr lang="en-US" sz="1050" dirty="0">
@@ -8338,15 +8330,14 @@
             </a:r>
           </a:p>
           <a:p>
-            <a:pPr marL="219456" indent="-219456" algn="l">
+            <a:pPr marL="18288" indent="0" algn="l">
               <a:spcBef>
                 <a:spcPts val="0"/>
               </a:spcBef>
               <a:spcAft>
                 <a:spcPts val="160"/>
               </a:spcAft>
-              <a:buFont typeface="Arial"/>
-              <a:buChar char="•"/>
+              <a:buNone/>
             </a:pPr>
             <a:r>
               <a:rPr lang="en-US" sz="1050" dirty="0">
@@ -8359,15 +8350,14 @@
             </a:r>
           </a:p>
           <a:p>
-            <a:pPr marL="219456" indent="-219456" algn="l">
+            <a:pPr marL="18288" indent="0" algn="l">
               <a:spcBef>
                 <a:spcPts val="0"/>
               </a:spcBef>
               <a:spcAft>
                 <a:spcPts val="160"/>
               </a:spcAft>
-              <a:buFont typeface="Arial"/>
-              <a:buChar char="•"/>
+              <a:buNone/>
             </a:pPr>
             <a:r>
               <a:rPr lang="en-US" sz="1050" dirty="0">
@@ -8380,15 +8370,14 @@
             </a:r>
           </a:p>
           <a:p>
-            <a:pPr marL="219456" indent="-219456" algn="l">
-              <a:spcBef>
-                <a:spcPts val="0"/>
-              </a:spcBef>
-              <a:spcAft>
-                <a:spcPts val="0"/>
-              </a:spcAft>
-              <a:buFont typeface="Arial"/>
-              <a:buChar char="•"/>
+            <a:pPr marL="18288" indent="0" algn="l">
+              <a:spcBef>
+                <a:spcPts val="0"/>
+              </a:spcBef>
+              <a:spcAft>
+                <a:spcPts val="0"/>
+              </a:spcAft>
+              <a:buNone/>
             </a:pPr>
             <a:r>
               <a:rPr lang="en-US" sz="1050" i="1" dirty="0">
@@ -8993,15 +8982,14 @@
             </a:r>
           </a:p>
           <a:p>
-            <a:pPr marL="256032" indent="-256032" algn="l">
+            <a:pPr marL="18288" indent="0" algn="l">
               <a:spcBef>
                 <a:spcPts val="0"/>
               </a:spcBef>
               <a:spcAft>
                 <a:spcPts val="120"/>
               </a:spcAft>
-              <a:buFont typeface="Arial"/>
-              <a:buChar char="•"/>
+              <a:buNone/>
             </a:pPr>
             <a:r>
               <a:rPr lang="en-US" sz="1300" b="1" dirty="0">
@@ -9023,15 +9011,14 @@
             </a:r>
           </a:p>
           <a:p>
-            <a:pPr marL="256032" indent="-256032" algn="l">
-              <a:spcBef>
-                <a:spcPts val="0"/>
-              </a:spcBef>
-              <a:spcAft>
-                <a:spcPts val="0"/>
-              </a:spcAft>
-              <a:buFont typeface="Arial"/>
-              <a:buChar char="•"/>
+            <a:pPr marL="18288" indent="0" algn="l">
+              <a:spcBef>
+                <a:spcPts val="0"/>
+              </a:spcBef>
+              <a:spcAft>
+                <a:spcPts val="0"/>
+              </a:spcAft>
+              <a:buNone/>
             </a:pPr>
             <a:r>
               <a:rPr lang="en-US" sz="1300" b="1" dirty="0">
@@ -11121,15 +11108,14 @@
           </a:bodyPr>
           <a:lstStyle/>
           <a:p>
-            <a:pPr marL="201168" indent="-201168" algn="l">
+            <a:pPr marL="18288" indent="0" algn="l">
               <a:spcBef>
                 <a:spcPts val="0"/>
               </a:spcBef>
               <a:spcAft>
                 <a:spcPts val="140"/>
               </a:spcAft>
-              <a:buFont typeface="Arial"/>
-              <a:buChar char="•"/>
+              <a:buNone/>
             </a:pPr>
             <a:r>
               <a:rPr lang="en-US" sz="1050" dirty="0">
@@ -11348,15 +11334,14 @@
           </a:bodyPr>
           <a:lstStyle/>
           <a:p>
-            <a:pPr marL="201168" indent="-201168" algn="l">
+            <a:pPr marL="18288" indent="0" algn="l">
               <a:spcBef>
                 <a:spcPts val="0"/>
               </a:spcBef>
               <a:spcAft>
                 <a:spcPts val="140"/>
               </a:spcAft>
-              <a:buFont typeface="Arial"/>
-              <a:buChar char="•"/>
+              <a:buNone/>
             </a:pPr>
             <a:r>
               <a:rPr lang="en-US" sz="1050" dirty="0">
@@ -11575,15 +11560,14 @@
           </a:bodyPr>
           <a:lstStyle/>
           <a:p>
-            <a:pPr marL="201168" indent="-201168" algn="l">
+            <a:pPr marL="18288" indent="0" algn="l">
               <a:spcBef>
                 <a:spcPts val="0"/>
               </a:spcBef>
               <a:spcAft>
                 <a:spcPts val="140"/>
               </a:spcAft>
-              <a:buFont typeface="Arial"/>
-              <a:buChar char="•"/>
+              <a:buNone/>
             </a:pPr>
             <a:r>
               <a:rPr lang="en-US" sz="1050" dirty="0">
@@ -11802,15 +11786,14 @@
           </a:bodyPr>
           <a:lstStyle/>
           <a:p>
-            <a:pPr marL="201168" indent="-201168" algn="l">
+            <a:pPr marL="18288" indent="0" algn="l">
               <a:spcBef>
                 <a:spcPts val="0"/>
               </a:spcBef>
               <a:spcAft>
                 <a:spcPts val="140"/>
               </a:spcAft>
-              <a:buFont typeface="Arial"/>
-              <a:buChar char="•"/>
+              <a:buNone/>
             </a:pPr>
             <a:r>
               <a:rPr lang="en-US" sz="1050" dirty="0">
@@ -14062,15 +14045,14 @@
           </a:bodyPr>
           <a:lstStyle/>
           <a:p>
-            <a:pPr marL="237744" indent="-237744" algn="l">
+            <a:pPr marL="18288" indent="0" algn="l">
               <a:spcBef>
                 <a:spcPts val="0"/>
               </a:spcBef>
               <a:spcAft>
                 <a:spcPts val="260"/>
               </a:spcAft>
-              <a:buFont typeface="Arial"/>
-              <a:buChar char="•"/>
+              <a:buNone/>
             </a:pPr>
             <a:r>
               <a:rPr lang="en-US" sz="1200" b="1" dirty="0">
@@ -14092,15 +14074,14 @@
             </a:r>
           </a:p>
           <a:p>
-            <a:pPr marL="237744" indent="-237744" algn="l">
+            <a:pPr marL="18288" indent="0" algn="l">
               <a:spcBef>
                 <a:spcPts val="0"/>
               </a:spcBef>
               <a:spcAft>
                 <a:spcPts val="260"/>
               </a:spcAft>
-              <a:buFont typeface="Arial"/>
-              <a:buChar char="•"/>
+              <a:buNone/>
             </a:pPr>
             <a:r>
               <a:rPr lang="en-US" sz="1200" b="1" dirty="0">
@@ -14122,15 +14103,14 @@
             </a:r>
           </a:p>
           <a:p>
-            <a:pPr marL="237744" indent="-237744" algn="l">
+            <a:pPr marL="18288" indent="0" algn="l">
               <a:spcBef>
                 <a:spcPts val="0"/>
               </a:spcBef>
               <a:spcAft>
                 <a:spcPts val="260"/>
               </a:spcAft>
-              <a:buFont typeface="Arial"/>
-              <a:buChar char="•"/>
+              <a:buNone/>
             </a:pPr>
             <a:r>
               <a:rPr lang="en-US" sz="1200" b="1" dirty="0">
@@ -14152,15 +14132,14 @@
             </a:r>
           </a:p>
           <a:p>
-            <a:pPr marL="237744" indent="-237744" algn="l">
+            <a:pPr marL="18288" indent="0" algn="l">
               <a:spcBef>
                 <a:spcPts val="0"/>
               </a:spcBef>
               <a:spcAft>
                 <a:spcPts val="260"/>
               </a:spcAft>
-              <a:buFont typeface="Arial"/>
-              <a:buChar char="•"/>
+              <a:buNone/>
             </a:pPr>
             <a:r>
               <a:rPr lang="en-US" sz="1200" b="1" dirty="0">
@@ -15465,15 +15444,14 @@
           </a:bodyPr>
           <a:lstStyle/>
           <a:p>
-            <a:pPr marL="201168" indent="-201168" algn="l">
+            <a:pPr marL="18288" indent="0" algn="l">
               <a:spcBef>
                 <a:spcPts val="0"/>
               </a:spcBef>
               <a:spcAft>
                 <a:spcPts val="140"/>
               </a:spcAft>
-              <a:buFont typeface="Arial"/>
-              <a:buChar char="•"/>
+              <a:buNone/>
             </a:pPr>
             <a:r>
               <a:rPr lang="en-US" sz="1050" dirty="0">
@@ -15620,15 +15598,14 @@
           </a:bodyPr>
           <a:lstStyle/>
           <a:p>
-            <a:pPr marL="201168" indent="-201168" algn="l">
+            <a:pPr marL="18288" indent="0" algn="l">
               <a:spcBef>
                 <a:spcPts val="0"/>
               </a:spcBef>
               <a:spcAft>
                 <a:spcPts val="140"/>
               </a:spcAft>
-              <a:buFont typeface="Arial"/>
-              <a:buChar char="•"/>
+              <a:buNone/>
             </a:pPr>
             <a:r>
               <a:rPr lang="en-US" sz="1050" dirty="0">
@@ -15775,15 +15752,14 @@
           </a:bodyPr>
           <a:lstStyle/>
           <a:p>
-            <a:pPr marL="201168" indent="-201168" algn="l">
+            <a:pPr marL="18288" indent="0" algn="l">
               <a:spcBef>
                 <a:spcPts val="0"/>
               </a:spcBef>
               <a:spcAft>
                 <a:spcPts val="140"/>
               </a:spcAft>
-              <a:buFont typeface="Arial"/>
-              <a:buChar char="•"/>
+              <a:buNone/>
             </a:pPr>
             <a:r>
               <a:rPr lang="en-US" sz="1050" dirty="0">
@@ -15930,15 +15906,14 @@
           </a:bodyPr>
           <a:lstStyle/>
           <a:p>
-            <a:pPr marL="201168" indent="-201168" algn="l">
+            <a:pPr marL="18288" indent="0" algn="l">
               <a:spcBef>
                 <a:spcPts val="0"/>
               </a:spcBef>
               <a:spcAft>
                 <a:spcPts val="140"/>
               </a:spcAft>
-              <a:buFont typeface="Arial"/>
-              <a:buChar char="•"/>
+              <a:buNone/>
             </a:pPr>
             <a:r>
               <a:rPr lang="en-US" sz="1050" dirty="0">
@@ -16085,15 +16060,14 @@
           </a:bodyPr>
           <a:lstStyle/>
           <a:p>
-            <a:pPr marL="201168" indent="-201168" algn="l">
+            <a:pPr marL="18288" indent="0" algn="l">
               <a:spcBef>
                 <a:spcPts val="0"/>
               </a:spcBef>
               <a:spcAft>
                 <a:spcPts val="140"/>
               </a:spcAft>
-              <a:buFont typeface="Arial"/>
-              <a:buChar char="•"/>
+              <a:buNone/>
             </a:pPr>
             <a:r>
               <a:rPr lang="en-US" sz="1050" dirty="0">
@@ -16240,15 +16214,14 @@
           </a:bodyPr>
           <a:lstStyle/>
           <a:p>
-            <a:pPr marL="201168" indent="-201168" algn="l">
+            <a:pPr marL="18288" indent="0" algn="l">
               <a:spcBef>
                 <a:spcPts val="0"/>
               </a:spcBef>
               <a:spcAft>
                 <a:spcPts val="140"/>
               </a:spcAft>
-              <a:buFont typeface="Arial"/>
-              <a:buChar char="•"/>
+              <a:buNone/>
             </a:pPr>
             <a:r>
               <a:rPr lang="en-US" sz="1050" dirty="0">
@@ -17416,15 +17389,14 @@
             </a:r>
           </a:p>
           <a:p>
-            <a:pPr marL="219456" indent="-219456" algn="l">
+            <a:pPr marL="18288" indent="0" algn="l">
               <a:spcBef>
                 <a:spcPts val="0"/>
               </a:spcBef>
               <a:spcAft>
                 <a:spcPts val="260"/>
               </a:spcAft>
-              <a:buFont typeface="Arial"/>
-              <a:buChar char="•"/>
+              <a:buNone/>
             </a:pPr>
             <a:r>
               <a:rPr lang="en-US" sz="1100" dirty="0">
@@ -17457,15 +17429,14 @@
             </a:r>
           </a:p>
           <a:p>
-            <a:pPr marL="219456" indent="-219456" algn="l">
+            <a:pPr marL="18288" indent="0" algn="l">
               <a:spcBef>
                 <a:spcPts val="0"/>
               </a:spcBef>
               <a:spcAft>
                 <a:spcPts val="120"/>
               </a:spcAft>
-              <a:buFont typeface="Arial"/>
-              <a:buChar char="•"/>
+              <a:buNone/>
             </a:pPr>
             <a:r>
               <a:rPr lang="en-US" sz="1100" dirty="0">
@@ -17478,15 +17449,14 @@
             </a:r>
           </a:p>
           <a:p>
-            <a:pPr marL="219456" indent="-219456" algn="l">
+            <a:pPr marL="18288" indent="0" algn="l">
               <a:spcBef>
                 <a:spcPts val="0"/>
               </a:spcBef>
               <a:spcAft>
                 <a:spcPts val="120"/>
               </a:spcAft>
-              <a:buFont typeface="Arial"/>
-              <a:buChar char="•"/>
+              <a:buNone/>
             </a:pPr>
             <a:r>
               <a:rPr lang="en-US" sz="1100" dirty="0">
@@ -17499,15 +17469,14 @@
             </a:r>
           </a:p>
           <a:p>
-            <a:pPr marL="219456" indent="-219456" algn="l">
+            <a:pPr marL="18288" indent="0" algn="l">
               <a:spcBef>
                 <a:spcPts val="0"/>
               </a:spcBef>
               <a:spcAft>
                 <a:spcPts val="120"/>
               </a:spcAft>
-              <a:buFont typeface="Arial"/>
-              <a:buChar char="•"/>
+              <a:buNone/>
             </a:pPr>
             <a:r>
               <a:rPr lang="en-US" sz="1100" dirty="0">
@@ -17520,15 +17489,14 @@
             </a:r>
           </a:p>
           <a:p>
-            <a:pPr marL="219456" indent="-219456" algn="l">
-              <a:spcBef>
-                <a:spcPts val="0"/>
-              </a:spcBef>
-              <a:spcAft>
-                <a:spcPts val="0"/>
-              </a:spcAft>
-              <a:buFont typeface="Arial"/>
-              <a:buChar char="•"/>
+            <a:pPr marL="18288" indent="0" algn="l">
+              <a:spcBef>
+                <a:spcPts val="0"/>
+              </a:spcBef>
+              <a:spcAft>
+                <a:spcPts val="0"/>
+              </a:spcAft>
+              <a:buNone/>
             </a:pPr>
             <a:r>
               <a:rPr lang="en-US" sz="1100" dirty="0">
@@ -18206,27 +18174,26 @@
             </a:r>
           </a:p>
           <a:p>
-            <a:pPr marL="237744" indent="-237744" algn="l">
+            <a:pPr marL="18288" indent="0" algn="l">
               <a:spcBef>
                 <a:spcPts val="0"/>
               </a:spcBef>
               <a:spcAft>
                 <a:spcPts val="300"/>
               </a:spcAft>
-              <a:buFont typeface="Arial"/>
-              <a:buChar char="•"/>
-            </a:pPr>
-            <a:r>
-              <a:rPr lang="en-US" sz="1150" b="1" dirty="0">
-                <a:solidFill>
-                  <a:srgbClr val="1F7A3D"/>
+              <a:buNone/>
+            </a:pPr>
+            <a:r>
+              <a:rPr lang="en-US" sz="1200" b="1" dirty="0">
+                <a:solidFill>
+                  <a:srgbClr val="17241E"/>
                 </a:solidFill>
                 <a:latin typeface="Calibri"/>
               </a:rPr>
               <a:t>SMAM  —  </a:t>
             </a:r>
             <a:r>
-              <a:rPr lang="en-US" sz="1150" dirty="0">
+              <a:rPr lang="en-US" sz="1200" dirty="0">
                 <a:solidFill>
                   <a:srgbClr val="5B6B63"/>
                 </a:solidFill>
@@ -18236,27 +18203,26 @@
             </a:r>
           </a:p>
           <a:p>
-            <a:pPr marL="237744" indent="-237744" algn="l">
+            <a:pPr marL="18288" indent="0" algn="l">
               <a:spcBef>
                 <a:spcPts val="0"/>
               </a:spcBef>
               <a:spcAft>
                 <a:spcPts val="300"/>
               </a:spcAft>
-              <a:buFont typeface="Arial"/>
-              <a:buChar char="•"/>
-            </a:pPr>
-            <a:r>
-              <a:rPr lang="en-US" sz="1150" b="1" dirty="0">
-                <a:solidFill>
-                  <a:srgbClr val="1F7A3D"/>
+              <a:buNone/>
+            </a:pPr>
+            <a:r>
+              <a:rPr lang="en-US" sz="1200" b="1" dirty="0">
+                <a:solidFill>
+                  <a:srgbClr val="17241E"/>
                 </a:solidFill>
                 <a:latin typeface="Calibri"/>
               </a:rPr>
               <a:t>Agri Infra Fund  —  </a:t>
             </a:r>
             <a:r>
-              <a:rPr lang="en-US" sz="1150" dirty="0">
+              <a:rPr lang="en-US" sz="1200" dirty="0">
                 <a:solidFill>
                   <a:srgbClr val="5B6B63"/>
                 </a:solidFill>
@@ -18266,27 +18232,26 @@
             </a:r>
           </a:p>
           <a:p>
-            <a:pPr marL="237744" indent="-237744" algn="l">
+            <a:pPr marL="18288" indent="0" algn="l">
               <a:spcBef>
                 <a:spcPts val="0"/>
               </a:spcBef>
               <a:spcAft>
                 <a:spcPts val="300"/>
               </a:spcAft>
-              <a:buFont typeface="Arial"/>
-              <a:buChar char="•"/>
-            </a:pPr>
-            <a:r>
-              <a:rPr lang="en-US" sz="1150" b="1" dirty="0">
-                <a:solidFill>
-                  <a:srgbClr val="1F7A3D"/>
+              <a:buNone/>
+            </a:pPr>
+            <a:r>
+              <a:rPr lang="en-US" sz="1200" b="1" dirty="0">
+                <a:solidFill>
+                  <a:srgbClr val="17241E"/>
                 </a:solidFill>
                 <a:latin typeface="Calibri"/>
               </a:rPr>
               <a:t>Namo Drone Didi  —  </a:t>
             </a:r>
             <a:r>
-              <a:rPr lang="en-US" sz="1150" dirty="0">
+              <a:rPr lang="en-US" sz="1200" dirty="0">
                 <a:solidFill>
                   <a:srgbClr val="5B6B63"/>
                 </a:solidFill>
@@ -18296,27 +18261,26 @@
             </a:r>
           </a:p>
           <a:p>
-            <a:pPr marL="237744" indent="-237744" algn="l">
+            <a:pPr marL="18288" indent="0" algn="l">
               <a:spcBef>
                 <a:spcPts val="0"/>
               </a:spcBef>
               <a:spcAft>
                 <a:spcPts val="300"/>
               </a:spcAft>
-              <a:buFont typeface="Arial"/>
-              <a:buChar char="•"/>
-            </a:pPr>
-            <a:r>
-              <a:rPr lang="en-US" sz="1150" b="1" dirty="0">
-                <a:solidFill>
-                  <a:srgbClr val="1F7A3D"/>
+              <a:buNone/>
+            </a:pPr>
+            <a:r>
+              <a:rPr lang="en-US" sz="1200" b="1" dirty="0">
+                <a:solidFill>
+                  <a:srgbClr val="17241E"/>
                 </a:solidFill>
                 <a:latin typeface="Calibri"/>
               </a:rPr>
               <a:t>Soil Health Card  —  </a:t>
             </a:r>
             <a:r>
-              <a:rPr lang="en-US" sz="1150" dirty="0">
+              <a:rPr lang="en-US" sz="1200" dirty="0">
                 <a:solidFill>
                   <a:srgbClr val="5B6B63"/>
                 </a:solidFill>
@@ -18407,15 +18371,14 @@
             </a:r>
           </a:p>
           <a:p>
-            <a:pPr marL="219456" indent="-219456" algn="l">
+            <a:pPr marL="18288" indent="0" algn="l">
               <a:spcBef>
                 <a:spcPts val="0"/>
               </a:spcBef>
               <a:spcAft>
                 <a:spcPts val="120"/>
               </a:spcAft>
-              <a:buFont typeface="Arial"/>
-              <a:buChar char="•"/>
+              <a:buNone/>
             </a:pPr>
             <a:r>
               <a:rPr lang="en-US" sz="1100" dirty="0">
@@ -18428,15 +18391,14 @@
             </a:r>
           </a:p>
           <a:p>
-            <a:pPr marL="219456" indent="-219456" algn="l">
+            <a:pPr marL="18288" indent="0" algn="l">
               <a:spcBef>
                 <a:spcPts val="0"/>
               </a:spcBef>
               <a:spcAft>
                 <a:spcPts val="260"/>
               </a:spcAft>
-              <a:buFont typeface="Arial"/>
-              <a:buChar char="•"/>
+              <a:buNone/>
             </a:pPr>
             <a:r>
               <a:rPr lang="en-US" sz="1100" dirty="0">
@@ -18469,15 +18431,14 @@
             </a:r>
           </a:p>
           <a:p>
-            <a:pPr marL="219456" indent="-219456" algn="l">
+            <a:pPr marL="18288" indent="0" algn="l">
               <a:spcBef>
                 <a:spcPts val="0"/>
               </a:spcBef>
               <a:spcAft>
                 <a:spcPts val="120"/>
               </a:spcAft>
-              <a:buFont typeface="Arial"/>
-              <a:buChar char="•"/>
+              <a:buNone/>
             </a:pPr>
             <a:r>
               <a:rPr lang="en-US" sz="1100" dirty="0">
@@ -18490,15 +18451,14 @@
             </a:r>
           </a:p>
           <a:p>
-            <a:pPr marL="219456" indent="-219456" algn="l">
+            <a:pPr marL="18288" indent="0" algn="l">
               <a:spcBef>
                 <a:spcPts val="0"/>
               </a:spcBef>
               <a:spcAft>
                 <a:spcPts val="120"/>
               </a:spcAft>
-              <a:buFont typeface="Arial"/>
-              <a:buChar char="•"/>
+              <a:buNone/>
             </a:pPr>
             <a:r>
               <a:rPr lang="en-US" sz="1100" dirty="0">
@@ -18511,15 +18471,14 @@
             </a:r>
           </a:p>
           <a:p>
-            <a:pPr marL="219456" indent="-219456" algn="l">
-              <a:spcBef>
-                <a:spcPts val="0"/>
-              </a:spcBef>
-              <a:spcAft>
-                <a:spcPts val="0"/>
-              </a:spcAft>
-              <a:buFont typeface="Arial"/>
-              <a:buChar char="•"/>
+            <a:pPr marL="18288" indent="0" algn="l">
+              <a:spcBef>
+                <a:spcPts val="0"/>
+              </a:spcBef>
+              <a:spcAft>
+                <a:spcPts val="0"/>
+              </a:spcAft>
+              <a:buNone/>
             </a:pPr>
             <a:r>
               <a:rPr lang="en-US" sz="1100" dirty="0">
@@ -19146,7 +19105,7 @@
                 </a:solidFill>
                 <a:latin typeface="Calibri"/>
               </a:rPr>
-              <a:t>●</a:t>
+              <a:t>✓</a:t>
             </a:r>
           </a:p>
         </p:txBody>
@@ -19216,15 +19175,14 @@
           </a:bodyPr>
           <a:lstStyle/>
           <a:p>
-            <a:pPr marL="201168" indent="-201168" algn="l">
+            <a:pPr marL="18288" indent="0" algn="l">
               <a:spcBef>
                 <a:spcPts val="0"/>
               </a:spcBef>
               <a:spcAft>
                 <a:spcPts val="140"/>
               </a:spcAft>
-              <a:buFont typeface="Arial"/>
-              <a:buChar char="•"/>
+              <a:buNone/>
             </a:pPr>
             <a:r>
               <a:rPr lang="en-US" sz="1050" dirty="0">
@@ -19237,15 +19195,14 @@
             </a:r>
           </a:p>
           <a:p>
-            <a:pPr marL="201168" indent="-201168" algn="l">
+            <a:pPr marL="18288" indent="0" algn="l">
               <a:spcBef>
                 <a:spcPts val="0"/>
               </a:spcBef>
               <a:spcAft>
                 <a:spcPts val="140"/>
               </a:spcAft>
-              <a:buFont typeface="Arial"/>
-              <a:buChar char="•"/>
+              <a:buNone/>
             </a:pPr>
             <a:r>
               <a:rPr lang="en-US" sz="1050" dirty="0">
@@ -19394,7 +19351,7 @@
                 </a:solidFill>
                 <a:latin typeface="Calibri"/>
               </a:rPr>
-              <a:t>●</a:t>
+              <a:t>✓</a:t>
             </a:r>
           </a:p>
         </p:txBody>
@@ -19464,15 +19421,14 @@
           </a:bodyPr>
           <a:lstStyle/>
           <a:p>
-            <a:pPr marL="201168" indent="-201168" algn="l">
+            <a:pPr marL="18288" indent="0" algn="l">
               <a:spcBef>
                 <a:spcPts val="0"/>
               </a:spcBef>
               <a:spcAft>
                 <a:spcPts val="140"/>
               </a:spcAft>
-              <a:buFont typeface="Arial"/>
-              <a:buChar char="•"/>
+              <a:buNone/>
             </a:pPr>
             <a:r>
               <a:rPr lang="en-US" sz="1050" dirty="0">
@@ -19485,15 +19441,14 @@
             </a:r>
           </a:p>
           <a:p>
-            <a:pPr marL="201168" indent="-201168" algn="l">
+            <a:pPr marL="18288" indent="0" algn="l">
               <a:spcBef>
                 <a:spcPts val="0"/>
               </a:spcBef>
               <a:spcAft>
                 <a:spcPts val="140"/>
               </a:spcAft>
-              <a:buFont typeface="Arial"/>
-              <a:buChar char="•"/>
+              <a:buNone/>
             </a:pPr>
             <a:r>
               <a:rPr lang="en-US" sz="1050" dirty="0">
@@ -19642,7 +19597,7 @@
                 </a:solidFill>
                 <a:latin typeface="Calibri"/>
               </a:rPr>
-              <a:t>●</a:t>
+              <a:t>✓</a:t>
             </a:r>
           </a:p>
         </p:txBody>
@@ -19712,15 +19667,14 @@
           </a:bodyPr>
           <a:lstStyle/>
           <a:p>
-            <a:pPr marL="201168" indent="-201168" algn="l">
+            <a:pPr marL="18288" indent="0" algn="l">
               <a:spcBef>
                 <a:spcPts val="0"/>
               </a:spcBef>
               <a:spcAft>
                 <a:spcPts val="140"/>
               </a:spcAft>
-              <a:buFont typeface="Arial"/>
-              <a:buChar char="•"/>
+              <a:buNone/>
             </a:pPr>
             <a:r>
               <a:rPr lang="en-US" sz="1050" dirty="0">
@@ -19733,15 +19687,14 @@
             </a:r>
           </a:p>
           <a:p>
-            <a:pPr marL="201168" indent="-201168" algn="l">
+            <a:pPr marL="18288" indent="0" algn="l">
               <a:spcBef>
                 <a:spcPts val="0"/>
               </a:spcBef>
               <a:spcAft>
                 <a:spcPts val="140"/>
               </a:spcAft>
-              <a:buFont typeface="Arial"/>
-              <a:buChar char="•"/>
+              <a:buNone/>
             </a:pPr>
             <a:r>
               <a:rPr lang="en-US" sz="1050" dirty="0">
@@ -19890,7 +19843,7 @@
                 </a:solidFill>
                 <a:latin typeface="Calibri"/>
               </a:rPr>
-              <a:t>●</a:t>
+              <a:t>✓</a:t>
             </a:r>
           </a:p>
         </p:txBody>
@@ -19960,15 +19913,14 @@
           </a:bodyPr>
           <a:lstStyle/>
           <a:p>
-            <a:pPr marL="201168" indent="-201168" algn="l">
+            <a:pPr marL="18288" indent="0" algn="l">
               <a:spcBef>
                 <a:spcPts val="0"/>
               </a:spcBef>
               <a:spcAft>
                 <a:spcPts val="140"/>
               </a:spcAft>
-              <a:buFont typeface="Arial"/>
-              <a:buChar char="•"/>
+              <a:buNone/>
             </a:pPr>
             <a:r>
               <a:rPr lang="en-US" sz="1050" dirty="0">
@@ -19981,15 +19933,14 @@
             </a:r>
           </a:p>
           <a:p>
-            <a:pPr marL="201168" indent="-201168" algn="l">
+            <a:pPr marL="18288" indent="0" algn="l">
               <a:spcBef>
                 <a:spcPts val="0"/>
               </a:spcBef>
               <a:spcAft>
                 <a:spcPts val="140"/>
               </a:spcAft>
-              <a:buFont typeface="Arial"/>
-              <a:buChar char="•"/>
+              <a:buNone/>
             </a:pPr>
             <a:r>
               <a:rPr lang="en-US" sz="1050" dirty="0">
@@ -20138,7 +20089,7 @@
                 </a:solidFill>
                 <a:latin typeface="Calibri"/>
               </a:rPr>
-              <a:t>●</a:t>
+              <a:t>✓</a:t>
             </a:r>
           </a:p>
         </p:txBody>
@@ -20208,15 +20159,14 @@
           </a:bodyPr>
           <a:lstStyle/>
           <a:p>
-            <a:pPr marL="201168" indent="-201168" algn="l">
+            <a:pPr marL="18288" indent="0" algn="l">
               <a:spcBef>
                 <a:spcPts val="0"/>
               </a:spcBef>
               <a:spcAft>
                 <a:spcPts val="140"/>
               </a:spcAft>
-              <a:buFont typeface="Arial"/>
-              <a:buChar char="•"/>
+              <a:buNone/>
             </a:pPr>
             <a:r>
               <a:rPr lang="en-US" sz="1050" dirty="0">
@@ -20229,15 +20179,14 @@
             </a:r>
           </a:p>
           <a:p>
-            <a:pPr marL="201168" indent="-201168" algn="l">
+            <a:pPr marL="18288" indent="0" algn="l">
               <a:spcBef>
                 <a:spcPts val="0"/>
               </a:spcBef>
               <a:spcAft>
                 <a:spcPts val="140"/>
               </a:spcAft>
-              <a:buFont typeface="Arial"/>
-              <a:buChar char="•"/>
+              <a:buNone/>
             </a:pPr>
             <a:r>
               <a:rPr lang="en-US" sz="1050" dirty="0">
@@ -20386,7 +20335,7 @@
                 </a:solidFill>
                 <a:latin typeface="Calibri"/>
               </a:rPr>
-              <a:t>●</a:t>
+              <a:t>✓</a:t>
             </a:r>
           </a:p>
         </p:txBody>
@@ -20456,15 +20405,14 @@
           </a:bodyPr>
           <a:lstStyle/>
           <a:p>
-            <a:pPr marL="201168" indent="-201168" algn="l">
+            <a:pPr marL="18288" indent="0" algn="l">
               <a:spcBef>
                 <a:spcPts val="0"/>
               </a:spcBef>
               <a:spcAft>
                 <a:spcPts val="140"/>
               </a:spcAft>
-              <a:buFont typeface="Arial"/>
-              <a:buChar char="•"/>
+              <a:buNone/>
             </a:pPr>
             <a:r>
               <a:rPr lang="en-US" sz="1050" dirty="0">
@@ -20477,15 +20425,14 @@
             </a:r>
           </a:p>
           <a:p>
-            <a:pPr marL="201168" indent="-201168" algn="l">
+            <a:pPr marL="18288" indent="0" algn="l">
               <a:spcBef>
                 <a:spcPts val="0"/>
               </a:spcBef>
               <a:spcAft>
                 <a:spcPts val="140"/>
               </a:spcAft>
-              <a:buFont typeface="Arial"/>
-              <a:buChar char="•"/>
+              <a:buNone/>
             </a:pPr>
             <a:r>
               <a:rPr lang="en-US" sz="1050" dirty="0">

</xml_diff>

<commit_message>
Fix slide3 text overflow (shorten+enlarge box, trim why-different) and slide11 empty space (remove leftover band, convert metrics to 3 cards)
</commit_message>
<xml_diff>
--- a/AgriRover_GrowwxIITB.pptx
+++ b/AgriRover_GrowwxIITB.pptx
@@ -6696,127 +6696,571 @@
       </p:sp>
       <p:sp>
         <p:nvSpPr>
-          <p:cNvPr id="14" name="TextBox 13"/>
-          <p:cNvSpPr txBox="1"/>
-          <p:nvPr/>
-        </p:nvSpPr>
-        <p:spPr>
-          <a:xfrm>
-            <a:off x="841248" y="2807208"/>
-            <a:ext cx="10509199" cy="2286000"/>
-          </a:xfrm>
-          <a:prstGeom prst="rect">
-            <a:avLst/>
-          </a:prstGeom>
-          <a:noFill/>
-        </p:spPr>
-        <p:txBody>
-          <a:bodyPr wrap="square" anchor="t" lIns="0" rIns="0" tIns="0" bIns="0">
-            <a:spAutoFit/>
-          </a:bodyPr>
-          <a:lstStyle/>
-          <a:p>
-            <a:pPr>
-              <a:lnSpc>
-                <a:spcPct val="106000"/>
-              </a:lnSpc>
-              <a:spcAft>
-                <a:spcPts val="900"/>
-              </a:spcAft>
-            </a:pPr>
-            <a:r>
-              <a:rPr sz="1500" b="1">
-                <a:solidFill>
-                  <a:srgbClr val="1F9254"/>
-                </a:solidFill>
-                <a:latin typeface="Segoe UI Semibold"/>
-              </a:rPr>
-              <a:t>Input reduction — fertiliser &amp; pesticide saved vs hand-broadcasting.</a:t>
-            </a:r>
-          </a:p>
-          <a:p>
-            <a:pPr>
-              <a:lnSpc>
-                <a:spcPct val="106000"/>
-              </a:lnSpc>
-              <a:spcAft>
-                <a:spcPts val="900"/>
-              </a:spcAft>
-            </a:pPr>
-            <a:r>
-              <a:rPr sz="1500" b="1">
-                <a:solidFill>
-                  <a:srgbClr val="1F9254"/>
-                </a:solidFill>
-                <a:latin typeface="Segoe UI Semibold"/>
-              </a:rPr>
-              <a:t>Detection accuracy — weed/disease precision &amp; recall; dosing placement (cm).</a:t>
-            </a:r>
-          </a:p>
-          <a:p>
-            <a:pPr>
-              <a:lnSpc>
-                <a:spcPct val="106000"/>
-              </a:lnSpc>
-              <a:spcAft>
-                <a:spcPts val="900"/>
-              </a:spcAft>
-            </a:pPr>
-            <a:r>
-              <a:rPr sz="1500" b="1">
-                <a:solidFill>
-                  <a:srgbClr val="1F9254"/>
-                </a:solidFill>
-                <a:latin typeface="Segoe UI Semibold"/>
-              </a:rPr>
-              <a:t>Coverage &amp; economics — area covered per charge; cost saving per acre.</a:t>
-            </a:r>
-          </a:p>
-        </p:txBody>
-      </p:sp>
-      <p:sp>
-        <p:nvSpPr>
-          <p:cNvPr id="15" name="Rounded Rectangle 14"/>
+          <p:cNvPr id="101" name="s101"/>
           <p:cNvSpPr/>
           <p:nvPr/>
         </p:nvSpPr>
         <p:spPr>
           <a:xfrm>
-            <a:off x="841248" y="4910328"/>
-            <a:ext cx="10509199" cy="685800"/>
+            <a:off x="838200" y="2857500"/>
+            <a:ext cx="3381375" cy="2238375"/>
           </a:xfrm>
           <a:prstGeom prst="roundRect">
             <a:avLst>
-              <a:gd name="adj" fmla="val 40000"/>
+              <a:gd name="adj" fmla="val 6000"/>
             </a:avLst>
           </a:prstGeom>
           <a:solidFill>
-            <a:srgbClr val="EEF4EC"/>
+            <a:srgbClr val="FFFFFF"/>
           </a:solidFill>
           <a:ln>
             <a:noFill/>
           </a:ln>
-          <a:effectLst/>
-        </p:spPr>
-        <p:style>
-          <a:lnRef idx="1">
-            <a:schemeClr val="accent1"/>
-          </a:lnRef>
-          <a:fillRef idx="3">
-            <a:schemeClr val="accent1"/>
-          </a:fillRef>
-          <a:effectRef idx="2">
-            <a:schemeClr val="accent1"/>
-          </a:effectRef>
-          <a:fontRef idx="minor">
-            <a:schemeClr val="lt1"/>
-          </a:fontRef>
-        </p:style>
-        <p:txBody>
-          <a:bodyPr rtlCol="0" anchor="ctr"/>
+        </p:spPr>
+        <p:txBody>
+          <a:bodyPr/>
+          <a:lstStyle/>
+          <a:p/>
+        </p:txBody>
+      </p:sp>
+      <p:sp>
+        <p:nvSpPr>
+          <p:cNvPr id="102" name="s102"/>
+          <p:cNvSpPr/>
+          <p:nvPr/>
+        </p:nvSpPr>
+        <p:spPr>
+          <a:xfrm>
+            <a:off x="838200" y="2857500"/>
+            <a:ext cx="104775" cy="2238375"/>
+          </a:xfrm>
+          <a:prstGeom prst="rect">
+            <a:avLst/>
+          </a:prstGeom>
+          <a:solidFill>
+            <a:srgbClr val="1F9254"/>
+          </a:solidFill>
+          <a:ln>
+            <a:noFill/>
+          </a:ln>
+        </p:spPr>
+        <p:txBody>
+          <a:bodyPr/>
+          <a:lstStyle/>
+          <a:p/>
+        </p:txBody>
+      </p:sp>
+      <p:sp>
+        <p:nvSpPr>
+          <p:cNvPr id="103" name="s103"/>
+          <p:cNvSpPr/>
+          <p:nvPr/>
+        </p:nvSpPr>
+        <p:spPr>
+          <a:xfrm>
+            <a:off x="1095375" y="3114675"/>
+            <a:ext cx="561975" cy="561975"/>
+          </a:xfrm>
+          <a:prstGeom prst="roundRect">
+            <a:avLst>
+              <a:gd name="adj" fmla="val 25000"/>
+            </a:avLst>
+          </a:prstGeom>
+          <a:solidFill>
+            <a:srgbClr val="1F9254"/>
+          </a:solidFill>
+          <a:ln>
+            <a:noFill/>
+          </a:ln>
+        </p:spPr>
+        <p:txBody>
+          <a:bodyPr/>
+          <a:lstStyle/>
+          <a:p/>
+        </p:txBody>
+      </p:sp>
+      <p:sp>
+        <p:nvSpPr>
+          <p:cNvPr id="104" name="c104"/>
+          <p:cNvSpPr txBox="1"/>
+          <p:nvPr/>
+        </p:nvSpPr>
+        <p:spPr>
+          <a:xfrm>
+            <a:off x="1095375" y="3133725"/>
+            <a:ext cx="561975" cy="561975"/>
+          </a:xfrm>
+          <a:prstGeom prst="rect">
+            <a:avLst/>
+          </a:prstGeom>
+          <a:noFill/>
+        </p:spPr>
+        <p:txBody>
+          <a:bodyPr wrap="square" anchor="ctr" rtlCol="0">
+            <a:normAutofit/>
+          </a:bodyPr>
           <a:lstStyle/>
           <a:p>
             <a:pPr algn="ctr"/>
+            <a:r>
+              <a:rPr lang="en-US" sz="1400" b="1" dirty="0">
+                <a:solidFill>
+                  <a:srgbClr val="FFFFFF"/>
+                </a:solidFill>
+                <a:latin typeface="Calibri"/>
+              </a:rPr>
+              <a:t>1</a:t>
+            </a:r>
+          </a:p>
+        </p:txBody>
+      </p:sp>
+      <p:sp>
+        <p:nvSpPr>
+          <p:cNvPr id="105" name="c105"/>
+          <p:cNvSpPr txBox="1"/>
+          <p:nvPr/>
+        </p:nvSpPr>
+        <p:spPr>
+          <a:xfrm>
+            <a:off x="1809750" y="3181350"/>
+            <a:ext cx="2286000" cy="381000"/>
+          </a:xfrm>
+          <a:prstGeom prst="rect">
+            <a:avLst/>
+          </a:prstGeom>
+          <a:noFill/>
+        </p:spPr>
+        <p:txBody>
+          <a:bodyPr wrap="square" anchor="t" rtlCol="0">
+            <a:normAutofit/>
+          </a:bodyPr>
+          <a:lstStyle/>
+          <a:p>
+            <a:pPr algn="l"/>
+            <a:r>
+              <a:rPr lang="en-US" sz="1400" b="1" dirty="0">
+                <a:solidFill>
+                  <a:srgbClr val="12281C"/>
+                </a:solidFill>
+                <a:latin typeface="Calibri"/>
+              </a:rPr>
+              <a:t>Input reduction</a:t>
+            </a:r>
+          </a:p>
+        </p:txBody>
+      </p:sp>
+      <p:sp>
+        <p:nvSpPr>
+          <p:cNvPr id="106" name="c106"/>
+          <p:cNvSpPr txBox="1"/>
+          <p:nvPr/>
+        </p:nvSpPr>
+        <p:spPr>
+          <a:xfrm>
+            <a:off x="1114425" y="3924300"/>
+            <a:ext cx="2857500" cy="1047750"/>
+          </a:xfrm>
+          <a:prstGeom prst="rect">
+            <a:avLst/>
+          </a:prstGeom>
+          <a:noFill/>
+        </p:spPr>
+        <p:txBody>
+          <a:bodyPr wrap="square" anchor="t" rtlCol="0">
+            <a:normAutofit/>
+          </a:bodyPr>
+          <a:lstStyle/>
+          <a:p>
+            <a:pPr algn="l"/>
+            <a:r>
+              <a:rPr lang="en-US" sz="1100" dirty="0">
+                <a:solidFill>
+                  <a:srgbClr val="5B6B62"/>
+                </a:solidFill>
+                <a:latin typeface="Calibri"/>
+              </a:rPr>
+              <a:t>Fertiliser &amp; pesticide saved vs hand-broadcasting.</a:t>
+            </a:r>
+          </a:p>
+        </p:txBody>
+      </p:sp>
+      <p:sp>
+        <p:nvSpPr>
+          <p:cNvPr id="110" name="s110"/>
+          <p:cNvSpPr/>
+          <p:nvPr/>
+        </p:nvSpPr>
+        <p:spPr>
+          <a:xfrm>
+            <a:off x="4400550" y="2857500"/>
+            <a:ext cx="3381375" cy="2238375"/>
+          </a:xfrm>
+          <a:prstGeom prst="roundRect">
+            <a:avLst>
+              <a:gd name="adj" fmla="val 6000"/>
+            </a:avLst>
+          </a:prstGeom>
+          <a:solidFill>
+            <a:srgbClr val="FFFFFF"/>
+          </a:solidFill>
+          <a:ln>
+            <a:noFill/>
+          </a:ln>
+        </p:spPr>
+        <p:txBody>
+          <a:bodyPr/>
+          <a:lstStyle/>
+          <a:p/>
+        </p:txBody>
+      </p:sp>
+      <p:sp>
+        <p:nvSpPr>
+          <p:cNvPr id="111" name="s111"/>
+          <p:cNvSpPr/>
+          <p:nvPr/>
+        </p:nvSpPr>
+        <p:spPr>
+          <a:xfrm>
+            <a:off x="4400550" y="2857500"/>
+            <a:ext cx="104775" cy="2238375"/>
+          </a:xfrm>
+          <a:prstGeom prst="rect">
+            <a:avLst/>
+          </a:prstGeom>
+          <a:solidFill>
+            <a:srgbClr val="2B9BD6"/>
+          </a:solidFill>
+          <a:ln>
+            <a:noFill/>
+          </a:ln>
+        </p:spPr>
+        <p:txBody>
+          <a:bodyPr/>
+          <a:lstStyle/>
+          <a:p/>
+        </p:txBody>
+      </p:sp>
+      <p:sp>
+        <p:nvSpPr>
+          <p:cNvPr id="112" name="s112"/>
+          <p:cNvSpPr/>
+          <p:nvPr/>
+        </p:nvSpPr>
+        <p:spPr>
+          <a:xfrm>
+            <a:off x="4657725" y="3114675"/>
+            <a:ext cx="561975" cy="561975"/>
+          </a:xfrm>
+          <a:prstGeom prst="roundRect">
+            <a:avLst>
+              <a:gd name="adj" fmla="val 25000"/>
+            </a:avLst>
+          </a:prstGeom>
+          <a:solidFill>
+            <a:srgbClr val="2B9BD6"/>
+          </a:solidFill>
+          <a:ln>
+            <a:noFill/>
+          </a:ln>
+        </p:spPr>
+        <p:txBody>
+          <a:bodyPr/>
+          <a:lstStyle/>
+          <a:p/>
+        </p:txBody>
+      </p:sp>
+      <p:sp>
+        <p:nvSpPr>
+          <p:cNvPr id="113" name="c113"/>
+          <p:cNvSpPr txBox="1"/>
+          <p:nvPr/>
+        </p:nvSpPr>
+        <p:spPr>
+          <a:xfrm>
+            <a:off x="4657725" y="3133725"/>
+            <a:ext cx="561975" cy="561975"/>
+          </a:xfrm>
+          <a:prstGeom prst="rect">
+            <a:avLst/>
+          </a:prstGeom>
+          <a:noFill/>
+        </p:spPr>
+        <p:txBody>
+          <a:bodyPr wrap="square" anchor="ctr" rtlCol="0">
+            <a:normAutofit/>
+          </a:bodyPr>
+          <a:lstStyle/>
+          <a:p>
+            <a:pPr algn="ctr"/>
+            <a:r>
+              <a:rPr lang="en-US" sz="1400" b="1" dirty="0">
+                <a:solidFill>
+                  <a:srgbClr val="FFFFFF"/>
+                </a:solidFill>
+                <a:latin typeface="Calibri"/>
+              </a:rPr>
+              <a:t>2</a:t>
+            </a:r>
+          </a:p>
+        </p:txBody>
+      </p:sp>
+      <p:sp>
+        <p:nvSpPr>
+          <p:cNvPr id="114" name="c114"/>
+          <p:cNvSpPr txBox="1"/>
+          <p:nvPr/>
+        </p:nvSpPr>
+        <p:spPr>
+          <a:xfrm>
+            <a:off x="5372100" y="3181350"/>
+            <a:ext cx="2286000" cy="381000"/>
+          </a:xfrm>
+          <a:prstGeom prst="rect">
+            <a:avLst/>
+          </a:prstGeom>
+          <a:noFill/>
+        </p:spPr>
+        <p:txBody>
+          <a:bodyPr wrap="square" anchor="t" rtlCol="0">
+            <a:normAutofit/>
+          </a:bodyPr>
+          <a:lstStyle/>
+          <a:p>
+            <a:pPr algn="l"/>
+            <a:r>
+              <a:rPr lang="en-US" sz="1400" b="1" dirty="0">
+                <a:solidFill>
+                  <a:srgbClr val="12281C"/>
+                </a:solidFill>
+                <a:latin typeface="Calibri"/>
+              </a:rPr>
+              <a:t>Detection accuracy</a:t>
+            </a:r>
+          </a:p>
+        </p:txBody>
+      </p:sp>
+      <p:sp>
+        <p:nvSpPr>
+          <p:cNvPr id="115" name="c115"/>
+          <p:cNvSpPr txBox="1"/>
+          <p:nvPr/>
+        </p:nvSpPr>
+        <p:spPr>
+          <a:xfrm>
+            <a:off x="4676775" y="3924300"/>
+            <a:ext cx="2857500" cy="1047750"/>
+          </a:xfrm>
+          <a:prstGeom prst="rect">
+            <a:avLst/>
+          </a:prstGeom>
+          <a:noFill/>
+        </p:spPr>
+        <p:txBody>
+          <a:bodyPr wrap="square" anchor="t" rtlCol="0">
+            <a:normAutofit/>
+          </a:bodyPr>
+          <a:lstStyle/>
+          <a:p>
+            <a:pPr algn="l"/>
+            <a:r>
+              <a:rPr lang="en-US" sz="1100" dirty="0">
+                <a:solidFill>
+                  <a:srgbClr val="5B6B62"/>
+                </a:solidFill>
+                <a:latin typeface="Calibri"/>
+              </a:rPr>
+              <a:t>Weed/disease precision &amp; recall; dosing placement (cm).</a:t>
+            </a:r>
+          </a:p>
+        </p:txBody>
+      </p:sp>
+      <p:sp>
+        <p:nvSpPr>
+          <p:cNvPr id="120" name="s120"/>
+          <p:cNvSpPr/>
+          <p:nvPr/>
+        </p:nvSpPr>
+        <p:spPr>
+          <a:xfrm>
+            <a:off x="7962900" y="2857500"/>
+            <a:ext cx="3381375" cy="2238375"/>
+          </a:xfrm>
+          <a:prstGeom prst="roundRect">
+            <a:avLst>
+              <a:gd name="adj" fmla="val 6000"/>
+            </a:avLst>
+          </a:prstGeom>
+          <a:solidFill>
+            <a:srgbClr val="FFFFFF"/>
+          </a:solidFill>
+          <a:ln>
+            <a:noFill/>
+          </a:ln>
+        </p:spPr>
+        <p:txBody>
+          <a:bodyPr/>
+          <a:lstStyle/>
+          <a:p/>
+        </p:txBody>
+      </p:sp>
+      <p:sp>
+        <p:nvSpPr>
+          <p:cNvPr id="121" name="s121"/>
+          <p:cNvSpPr/>
+          <p:nvPr/>
+        </p:nvSpPr>
+        <p:spPr>
+          <a:xfrm>
+            <a:off x="7962900" y="2857500"/>
+            <a:ext cx="104775" cy="2238375"/>
+          </a:xfrm>
+          <a:prstGeom prst="rect">
+            <a:avLst/>
+          </a:prstGeom>
+          <a:solidFill>
+            <a:srgbClr val="F2A03D"/>
+          </a:solidFill>
+          <a:ln>
+            <a:noFill/>
+          </a:ln>
+        </p:spPr>
+        <p:txBody>
+          <a:bodyPr/>
+          <a:lstStyle/>
+          <a:p/>
+        </p:txBody>
+      </p:sp>
+      <p:sp>
+        <p:nvSpPr>
+          <p:cNvPr id="122" name="s122"/>
+          <p:cNvSpPr/>
+          <p:nvPr/>
+        </p:nvSpPr>
+        <p:spPr>
+          <a:xfrm>
+            <a:off x="8220075" y="3114675"/>
+            <a:ext cx="561975" cy="561975"/>
+          </a:xfrm>
+          <a:prstGeom prst="roundRect">
+            <a:avLst>
+              <a:gd name="adj" fmla="val 25000"/>
+            </a:avLst>
+          </a:prstGeom>
+          <a:solidFill>
+            <a:srgbClr val="F2A03D"/>
+          </a:solidFill>
+          <a:ln>
+            <a:noFill/>
+          </a:ln>
+        </p:spPr>
+        <p:txBody>
+          <a:bodyPr/>
+          <a:lstStyle/>
+          <a:p/>
+        </p:txBody>
+      </p:sp>
+      <p:sp>
+        <p:nvSpPr>
+          <p:cNvPr id="123" name="c123"/>
+          <p:cNvSpPr txBox="1"/>
+          <p:nvPr/>
+        </p:nvSpPr>
+        <p:spPr>
+          <a:xfrm>
+            <a:off x="8220075" y="3133725"/>
+            <a:ext cx="561975" cy="561975"/>
+          </a:xfrm>
+          <a:prstGeom prst="rect">
+            <a:avLst/>
+          </a:prstGeom>
+          <a:noFill/>
+        </p:spPr>
+        <p:txBody>
+          <a:bodyPr wrap="square" anchor="ctr" rtlCol="0">
+            <a:normAutofit/>
+          </a:bodyPr>
+          <a:lstStyle/>
+          <a:p>
+            <a:pPr algn="ctr"/>
+            <a:r>
+              <a:rPr lang="en-US" sz="1400" b="1" dirty="0">
+                <a:solidFill>
+                  <a:srgbClr val="FFFFFF"/>
+                </a:solidFill>
+                <a:latin typeface="Calibri"/>
+              </a:rPr>
+              <a:t>3</a:t>
+            </a:r>
+          </a:p>
+        </p:txBody>
+      </p:sp>
+      <p:sp>
+        <p:nvSpPr>
+          <p:cNvPr id="124" name="c124"/>
+          <p:cNvSpPr txBox="1"/>
+          <p:nvPr/>
+        </p:nvSpPr>
+        <p:spPr>
+          <a:xfrm>
+            <a:off x="8934450" y="3181350"/>
+            <a:ext cx="2286000" cy="381000"/>
+          </a:xfrm>
+          <a:prstGeom prst="rect">
+            <a:avLst/>
+          </a:prstGeom>
+          <a:noFill/>
+        </p:spPr>
+        <p:txBody>
+          <a:bodyPr wrap="square" anchor="t" rtlCol="0">
+            <a:normAutofit/>
+          </a:bodyPr>
+          <a:lstStyle/>
+          <a:p>
+            <a:pPr algn="l"/>
+            <a:r>
+              <a:rPr lang="en-US" sz="1400" b="1" dirty="0">
+                <a:solidFill>
+                  <a:srgbClr val="12281C"/>
+                </a:solidFill>
+                <a:latin typeface="Calibri"/>
+              </a:rPr>
+              <a:t>Coverage &amp; economics</a:t>
+            </a:r>
+          </a:p>
+        </p:txBody>
+      </p:sp>
+      <p:sp>
+        <p:nvSpPr>
+          <p:cNvPr id="125" name="c125"/>
+          <p:cNvSpPr txBox="1"/>
+          <p:nvPr/>
+        </p:nvSpPr>
+        <p:spPr>
+          <a:xfrm>
+            <a:off x="8239125" y="3924300"/>
+            <a:ext cx="2857500" cy="1047750"/>
+          </a:xfrm>
+          <a:prstGeom prst="rect">
+            <a:avLst/>
+          </a:prstGeom>
+          <a:noFill/>
+        </p:spPr>
+        <p:txBody>
+          <a:bodyPr wrap="square" anchor="t" rtlCol="0">
+            <a:normAutofit/>
+          </a:bodyPr>
+          <a:lstStyle/>
+          <a:p>
+            <a:pPr algn="l"/>
+            <a:r>
+              <a:rPr lang="en-US" sz="1100" dirty="0">
+                <a:solidFill>
+                  <a:srgbClr val="5B6B62"/>
+                </a:solidFill>
+                <a:latin typeface="Calibri"/>
+              </a:rPr>
+              <a:t>Area covered per charge; cost saving per acre.</a:t>
+            </a:r>
           </a:p>
         </p:txBody>
       </p:sp>
@@ -18890,7 +19334,7 @@
         <p:spPr>
           <a:xfrm>
             <a:off x="841248" y="1664208"/>
-            <a:ext cx="10509199" cy="502920"/>
+            <a:ext cx="10509199" cy="647700"/>
           </a:xfrm>
           <a:prstGeom prst="rect">
             <a:avLst/>
@@ -18921,7 +19365,7 @@
                 </a:solidFill>
                 <a:latin typeface="Calibri"/>
               </a:rPr>
-              <a:t>An autonomous rover that closes the sense–decide–act loop for each plant: it measures soil N-P-K, pH and moisture, identifies weeds and disease with AI vision (YOLOv8n on an edge TPU), then actuates precise per-plant dosing and targeted spraying — logging geo-tagged data into a prescription map.</a:t>
+              <a:t>An autonomous rover that senses each plant's soil (N-P-K, pH, moisture), uses AI vision (YOLOv8n on an edge TPU) to detect weeds and disease, then doses and sprays precisely — closing the sense-decide-act loop.</a:t>
             </a:r>
           </a:p>
         </p:txBody>
@@ -20118,7 +20562,7 @@
                 </a:solidFill>
                 <a:latin typeface="Segoe UI Semibold"/>
               </a:rPr>
-              <a:t>Why it's different: the only autonomous, per-plant solution that also senses the soil — built for small farms.</a:t>
+              <a:t>Why it's different: the only autonomous, per-plant solution that also senses the soil.</a:t>
             </a:r>
           </a:p>
         </p:txBody>

</xml_diff>

<commit_message>
Add production-intent AgriRover build: Pi5+Hailo AI, ROS2, deploy, CAD, decks, research, tests
Brings the add-agrirover-pitch-deck branch up to the current working state
(239 files changed, +76503/-1776 vs the previous branch tip).

Highlights:
- Raspberry Pi 5 + Hailo-8 primary inference path with Coral/CPU fallback,
  active-learning frame capture, and model OTA updates
- ROS 2 package (sensor / drive / AI / mission nodes)
- Hardened deploy: TLS MQTT, systemd units, model-OTA timer, Pi hardening
- Fusion 360 CAD generator and to-scale mechanical layout
- Investor pitch decks plus python-pptx deck generators and assets
- Market-adoption and agri-problem research dossiers
- pytest suite and expanded hardware / field documentation

Excluded via .gitignore: real secrets (.env, secrets.h), model binaries,
build caches, and agent-tooling directories (.claude, .workbuddy-ai).
</commit_message>
<xml_diff>
--- a/AgriRover_GrowwxIITB.pptx
+++ b/AgriRover_GrowwxIITB.pptx
@@ -6297,7 +6297,7 @@
                 </a:solidFill>
                 <a:latin typeface="Segoe UI Semibold"/>
               </a:rPr>
-              <a:t>PILOT METRICS</a:t>
+              <a:t>POC HYPOTHESIS &amp; METRICS</a:t>
             </a:r>
           </a:p>
         </p:txBody>
@@ -6342,7 +6342,7 @@
                 </a:solidFill>
                 <a:latin typeface="Segoe UI Semibold"/>
               </a:rPr>
-              <a:t>What we will measure</a:t>
+              <a:t>What we will prove</a:t>
             </a:r>
           </a:p>
         </p:txBody>
@@ -6689,106 +6689,210 @@
                 </a:solidFill>
                 <a:latin typeface="Segoe UI Semibold"/>
               </a:rPr>
-              <a:t>What we will measure in the field pilot — on real farms, not assumptions:</a:t>
-            </a:r>
-          </a:p>
-        </p:txBody>
-      </p:sp>
-      <p:sp>
-        <p:nvSpPr>
-          <p:cNvPr id="101" name="s101"/>
+              <a:t>Hypothesis:  </a:t>
+            </a:r>
+            <a:r>
+              <a:rPr sz="1350" b="0">
+                <a:solidFill>
+                  <a:srgbClr val="12281C"/>
+                </a:solidFill>
+                <a:latin typeface="Calibri"/>
+              </a:rPr>
+              <a:t>per-plant sensing + targeted dosing cuts fertiliser/chemical use sharply — with no yield loss.</a:t>
+            </a:r>
+          </a:p>
+        </p:txBody>
+      </p:sp>
+      <p:sp>
+        <p:nvSpPr>
+          <p:cNvPr id="14" name="TextBox 13"/>
+          <p:cNvSpPr txBox="1"/>
+          <p:nvPr/>
+        </p:nvSpPr>
+        <p:spPr>
+          <a:xfrm>
+            <a:off x="841248" y="2807208"/>
+            <a:ext cx="10509199" cy="2286000"/>
+          </a:xfrm>
+          <a:prstGeom prst="rect">
+            <a:avLst/>
+          </a:prstGeom>
+          <a:noFill/>
+        </p:spPr>
+        <p:txBody>
+          <a:bodyPr wrap="square" anchor="t" lIns="0" rIns="0" tIns="0" bIns="0">
+            <a:spAutoFit/>
+          </a:bodyPr>
+          <a:lstStyle/>
+          <a:p>
+            <a:pPr>
+              <a:lnSpc>
+                <a:spcPct val="106000"/>
+              </a:lnSpc>
+              <a:spcAft>
+                <a:spcPts val="900"/>
+              </a:spcAft>
+            </a:pPr>
+            <a:r>
+              <a:rPr sz="1500" b="1">
+                <a:solidFill>
+                  <a:srgbClr val="1F9254"/>
+                </a:solidFill>
+                <a:latin typeface="Segoe UI Semibold"/>
+              </a:rPr>
+              <a:t>▸  </a:t>
+            </a:r>
+            <a:r>
+              <a:rPr sz="1500" b="1">
+                <a:solidFill>
+                  <a:srgbClr val="12281C"/>
+                </a:solidFill>
+                <a:latin typeface="Calibri"/>
+              </a:rPr>
+              <a:t>Input reduction</a:t>
+            </a:r>
+            <a:r>
+              <a:rPr sz="1350" b="0">
+                <a:solidFill>
+                  <a:srgbClr val="5B6B62"/>
+                </a:solidFill>
+                <a:latin typeface="Calibri"/>
+              </a:rPr>
+              <a:t>  —  fertiliser &amp; pesticide saved vs hand-broadcasting</a:t>
+            </a:r>
+          </a:p>
+          <a:p>
+            <a:pPr>
+              <a:lnSpc>
+                <a:spcPct val="106000"/>
+              </a:lnSpc>
+              <a:spcAft>
+                <a:spcPts val="900"/>
+              </a:spcAft>
+            </a:pPr>
+            <a:r>
+              <a:rPr sz="1500" b="1">
+                <a:solidFill>
+                  <a:srgbClr val="1F9254"/>
+                </a:solidFill>
+                <a:latin typeface="Segoe UI Semibold"/>
+              </a:rPr>
+              <a:t>▸  </a:t>
+            </a:r>
+            <a:r>
+              <a:rPr sz="1500" b="1">
+                <a:solidFill>
+                  <a:srgbClr val="12281C"/>
+                </a:solidFill>
+                <a:latin typeface="Calibri"/>
+              </a:rPr>
+              <a:t>Detection accuracy</a:t>
+            </a:r>
+            <a:r>
+              <a:rPr sz="1350" b="0">
+                <a:solidFill>
+                  <a:srgbClr val="5B6B62"/>
+                </a:solidFill>
+                <a:latin typeface="Calibri"/>
+              </a:rPr>
+              <a:t>  —  weed/disease precision &amp; recall; dosing placement (cm)</a:t>
+            </a:r>
+          </a:p>
+          <a:p>
+            <a:pPr>
+              <a:lnSpc>
+                <a:spcPct val="106000"/>
+              </a:lnSpc>
+              <a:spcAft>
+                <a:spcPts val="900"/>
+              </a:spcAft>
+            </a:pPr>
+            <a:r>
+              <a:rPr sz="1500" b="1">
+                <a:solidFill>
+                  <a:srgbClr val="1F9254"/>
+                </a:solidFill>
+                <a:latin typeface="Segoe UI Semibold"/>
+              </a:rPr>
+              <a:t>▸  </a:t>
+            </a:r>
+            <a:r>
+              <a:rPr sz="1500" b="1">
+                <a:solidFill>
+                  <a:srgbClr val="12281C"/>
+                </a:solidFill>
+                <a:latin typeface="Calibri"/>
+              </a:rPr>
+              <a:t>Coverage &amp; economics</a:t>
+            </a:r>
+            <a:r>
+              <a:rPr sz="1350" b="0">
+                <a:solidFill>
+                  <a:srgbClr val="5B6B62"/>
+                </a:solidFill>
+                <a:latin typeface="Calibri"/>
+              </a:rPr>
+              <a:t>  —  area per charge; cost saving per acre per season</a:t>
+            </a:r>
+          </a:p>
+        </p:txBody>
+      </p:sp>
+      <p:sp>
+        <p:nvSpPr>
+          <p:cNvPr id="15" name="Rounded Rectangle 14"/>
           <p:cNvSpPr/>
           <p:nvPr/>
         </p:nvSpPr>
         <p:spPr>
           <a:xfrm>
-            <a:off x="838200" y="2857500"/>
-            <a:ext cx="3381375" cy="2238375"/>
+            <a:off x="841248" y="4910328"/>
+            <a:ext cx="10509199" cy="685800"/>
           </a:xfrm>
           <a:prstGeom prst="roundRect">
             <a:avLst>
-              <a:gd name="adj" fmla="val 6000"/>
+              <a:gd name="adj" fmla="val 40000"/>
             </a:avLst>
           </a:prstGeom>
           <a:solidFill>
-            <a:srgbClr val="FFFFFF"/>
+            <a:srgbClr val="EEF4EC"/>
           </a:solidFill>
           <a:ln>
             <a:noFill/>
           </a:ln>
-        </p:spPr>
-        <p:txBody>
-          <a:bodyPr/>
-          <a:lstStyle/>
-          <a:p/>
-        </p:txBody>
-      </p:sp>
-      <p:sp>
-        <p:nvSpPr>
-          <p:cNvPr id="102" name="s102"/>
-          <p:cNvSpPr/>
-          <p:nvPr/>
-        </p:nvSpPr>
-        <p:spPr>
-          <a:xfrm>
-            <a:off x="838200" y="2857500"/>
-            <a:ext cx="104775" cy="2238375"/>
-          </a:xfrm>
-          <a:prstGeom prst="rect">
-            <a:avLst/>
-          </a:prstGeom>
-          <a:solidFill>
-            <a:srgbClr val="1F9254"/>
-          </a:solidFill>
-          <a:ln>
-            <a:noFill/>
-          </a:ln>
-        </p:spPr>
-        <p:txBody>
-          <a:bodyPr/>
-          <a:lstStyle/>
-          <a:p/>
-        </p:txBody>
-      </p:sp>
-      <p:sp>
-        <p:nvSpPr>
-          <p:cNvPr id="103" name="s103"/>
-          <p:cNvSpPr/>
-          <p:nvPr/>
-        </p:nvSpPr>
-        <p:spPr>
-          <a:xfrm>
-            <a:off x="1095375" y="3114675"/>
-            <a:ext cx="561975" cy="561975"/>
-          </a:xfrm>
-          <a:prstGeom prst="roundRect">
-            <a:avLst>
-              <a:gd name="adj" fmla="val 25000"/>
-            </a:avLst>
-          </a:prstGeom>
-          <a:solidFill>
-            <a:srgbClr val="1F9254"/>
-          </a:solidFill>
-          <a:ln>
-            <a:noFill/>
-          </a:ln>
-        </p:spPr>
-        <p:txBody>
-          <a:bodyPr/>
-          <a:lstStyle/>
-          <a:p/>
-        </p:txBody>
-      </p:sp>
-      <p:sp>
-        <p:nvSpPr>
-          <p:cNvPr id="104" name="c104"/>
+          <a:effectLst/>
+        </p:spPr>
+        <p:style>
+          <a:lnRef idx="1">
+            <a:schemeClr val="accent1"/>
+          </a:lnRef>
+          <a:fillRef idx="3">
+            <a:schemeClr val="accent1"/>
+          </a:fillRef>
+          <a:effectRef idx="2">
+            <a:schemeClr val="accent1"/>
+          </a:effectRef>
+          <a:fontRef idx="minor">
+            <a:schemeClr val="lt1"/>
+          </a:fontRef>
+        </p:style>
+        <p:txBody>
+          <a:bodyPr rtlCol="0" anchor="ctr"/>
+          <a:lstStyle/>
+          <a:p>
+            <a:pPr algn="ctr"/>
+          </a:p>
+        </p:txBody>
+      </p:sp>
+      <p:sp>
+        <p:nvSpPr>
+          <p:cNvPr id="16" name="TextBox 15"/>
           <p:cNvSpPr txBox="1"/>
           <p:nvPr/>
         </p:nvSpPr>
         <p:spPr>
           <a:xfrm>
-            <a:off x="1095375" y="3133725"/>
-            <a:ext cx="561975" cy="561975"/>
+            <a:off x="1115568" y="4910328"/>
+            <a:ext cx="9960559" cy="685800"/>
           </a:xfrm>
           <a:prstGeom prst="rect">
             <a:avLst/>
@@ -6796,470 +6900,29 @@
           <a:noFill/>
         </p:spPr>
         <p:txBody>
-          <a:bodyPr wrap="square" anchor="ctr" rtlCol="0">
-            <a:normAutofit/>
+          <a:bodyPr wrap="square" anchor="ctr" lIns="0" rIns="0" tIns="0" bIns="0">
+            <a:spAutoFit/>
           </a:bodyPr>
           <a:lstStyle/>
           <a:p>
             <a:pPr algn="ctr"/>
             <a:r>
-              <a:rPr lang="en-US" sz="1400" b="1" dirty="0">
-                <a:solidFill>
-                  <a:srgbClr val="FFFFFF"/>
+              <a:rPr sz="1400" b="1">
+                <a:solidFill>
+                  <a:srgbClr val="F2A03D"/>
+                </a:solidFill>
+                <a:latin typeface="Segoe UI Semibold"/>
+              </a:rPr>
+              <a:t>Targets to prove in pilot:  </a:t>
+            </a:r>
+            <a:r>
+              <a:rPr sz="1400" b="1">
+                <a:solidFill>
+                  <a:srgbClr val="12281C"/>
                 </a:solidFill>
                 <a:latin typeface="Calibri"/>
               </a:rPr>
-              <a:t>1</a:t>
-            </a:r>
-          </a:p>
-        </p:txBody>
-      </p:sp>
-      <p:sp>
-        <p:nvSpPr>
-          <p:cNvPr id="105" name="c105"/>
-          <p:cNvSpPr txBox="1"/>
-          <p:nvPr/>
-        </p:nvSpPr>
-        <p:spPr>
-          <a:xfrm>
-            <a:off x="1809750" y="3181350"/>
-            <a:ext cx="2286000" cy="381000"/>
-          </a:xfrm>
-          <a:prstGeom prst="rect">
-            <a:avLst/>
-          </a:prstGeom>
-          <a:noFill/>
-        </p:spPr>
-        <p:txBody>
-          <a:bodyPr wrap="square" anchor="t" rtlCol="0">
-            <a:normAutofit/>
-          </a:bodyPr>
-          <a:lstStyle/>
-          <a:p>
-            <a:pPr algn="l"/>
-            <a:r>
-              <a:rPr lang="en-US" sz="1400" b="1" dirty="0">
-                <a:solidFill>
-                  <a:srgbClr val="12281C"/>
-                </a:solidFill>
-                <a:latin typeface="Calibri"/>
-              </a:rPr>
-              <a:t>Input reduction</a:t>
-            </a:r>
-          </a:p>
-        </p:txBody>
-      </p:sp>
-      <p:sp>
-        <p:nvSpPr>
-          <p:cNvPr id="106" name="c106"/>
-          <p:cNvSpPr txBox="1"/>
-          <p:nvPr/>
-        </p:nvSpPr>
-        <p:spPr>
-          <a:xfrm>
-            <a:off x="1114425" y="3924300"/>
-            <a:ext cx="2857500" cy="1047750"/>
-          </a:xfrm>
-          <a:prstGeom prst="rect">
-            <a:avLst/>
-          </a:prstGeom>
-          <a:noFill/>
-        </p:spPr>
-        <p:txBody>
-          <a:bodyPr wrap="square" anchor="t" rtlCol="0">
-            <a:normAutofit/>
-          </a:bodyPr>
-          <a:lstStyle/>
-          <a:p>
-            <a:pPr algn="l"/>
-            <a:r>
-              <a:rPr lang="en-US" sz="1100" dirty="0">
-                <a:solidFill>
-                  <a:srgbClr val="5B6B62"/>
-                </a:solidFill>
-                <a:latin typeface="Calibri"/>
-              </a:rPr>
-              <a:t>Fertiliser &amp; pesticide saved vs hand-broadcasting.</a:t>
-            </a:r>
-          </a:p>
-        </p:txBody>
-      </p:sp>
-      <p:sp>
-        <p:nvSpPr>
-          <p:cNvPr id="110" name="s110"/>
-          <p:cNvSpPr/>
-          <p:nvPr/>
-        </p:nvSpPr>
-        <p:spPr>
-          <a:xfrm>
-            <a:off x="4400550" y="2857500"/>
-            <a:ext cx="3381375" cy="2238375"/>
-          </a:xfrm>
-          <a:prstGeom prst="roundRect">
-            <a:avLst>
-              <a:gd name="adj" fmla="val 6000"/>
-            </a:avLst>
-          </a:prstGeom>
-          <a:solidFill>
-            <a:srgbClr val="FFFFFF"/>
-          </a:solidFill>
-          <a:ln>
-            <a:noFill/>
-          </a:ln>
-        </p:spPr>
-        <p:txBody>
-          <a:bodyPr/>
-          <a:lstStyle/>
-          <a:p/>
-        </p:txBody>
-      </p:sp>
-      <p:sp>
-        <p:nvSpPr>
-          <p:cNvPr id="111" name="s111"/>
-          <p:cNvSpPr/>
-          <p:nvPr/>
-        </p:nvSpPr>
-        <p:spPr>
-          <a:xfrm>
-            <a:off x="4400550" y="2857500"/>
-            <a:ext cx="104775" cy="2238375"/>
-          </a:xfrm>
-          <a:prstGeom prst="rect">
-            <a:avLst/>
-          </a:prstGeom>
-          <a:solidFill>
-            <a:srgbClr val="2B9BD6"/>
-          </a:solidFill>
-          <a:ln>
-            <a:noFill/>
-          </a:ln>
-        </p:spPr>
-        <p:txBody>
-          <a:bodyPr/>
-          <a:lstStyle/>
-          <a:p/>
-        </p:txBody>
-      </p:sp>
-      <p:sp>
-        <p:nvSpPr>
-          <p:cNvPr id="112" name="s112"/>
-          <p:cNvSpPr/>
-          <p:nvPr/>
-        </p:nvSpPr>
-        <p:spPr>
-          <a:xfrm>
-            <a:off x="4657725" y="3114675"/>
-            <a:ext cx="561975" cy="561975"/>
-          </a:xfrm>
-          <a:prstGeom prst="roundRect">
-            <a:avLst>
-              <a:gd name="adj" fmla="val 25000"/>
-            </a:avLst>
-          </a:prstGeom>
-          <a:solidFill>
-            <a:srgbClr val="2B9BD6"/>
-          </a:solidFill>
-          <a:ln>
-            <a:noFill/>
-          </a:ln>
-        </p:spPr>
-        <p:txBody>
-          <a:bodyPr/>
-          <a:lstStyle/>
-          <a:p/>
-        </p:txBody>
-      </p:sp>
-      <p:sp>
-        <p:nvSpPr>
-          <p:cNvPr id="113" name="c113"/>
-          <p:cNvSpPr txBox="1"/>
-          <p:nvPr/>
-        </p:nvSpPr>
-        <p:spPr>
-          <a:xfrm>
-            <a:off x="4657725" y="3133725"/>
-            <a:ext cx="561975" cy="561975"/>
-          </a:xfrm>
-          <a:prstGeom prst="rect">
-            <a:avLst/>
-          </a:prstGeom>
-          <a:noFill/>
-        </p:spPr>
-        <p:txBody>
-          <a:bodyPr wrap="square" anchor="ctr" rtlCol="0">
-            <a:normAutofit/>
-          </a:bodyPr>
-          <a:lstStyle/>
-          <a:p>
-            <a:pPr algn="ctr"/>
-            <a:r>
-              <a:rPr lang="en-US" sz="1400" b="1" dirty="0">
-                <a:solidFill>
-                  <a:srgbClr val="FFFFFF"/>
-                </a:solidFill>
-                <a:latin typeface="Calibri"/>
-              </a:rPr>
-              <a:t>2</a:t>
-            </a:r>
-          </a:p>
-        </p:txBody>
-      </p:sp>
-      <p:sp>
-        <p:nvSpPr>
-          <p:cNvPr id="114" name="c114"/>
-          <p:cNvSpPr txBox="1"/>
-          <p:nvPr/>
-        </p:nvSpPr>
-        <p:spPr>
-          <a:xfrm>
-            <a:off x="5372100" y="3181350"/>
-            <a:ext cx="2286000" cy="381000"/>
-          </a:xfrm>
-          <a:prstGeom prst="rect">
-            <a:avLst/>
-          </a:prstGeom>
-          <a:noFill/>
-        </p:spPr>
-        <p:txBody>
-          <a:bodyPr wrap="square" anchor="t" rtlCol="0">
-            <a:normAutofit/>
-          </a:bodyPr>
-          <a:lstStyle/>
-          <a:p>
-            <a:pPr algn="l"/>
-            <a:r>
-              <a:rPr lang="en-US" sz="1400" b="1" dirty="0">
-                <a:solidFill>
-                  <a:srgbClr val="12281C"/>
-                </a:solidFill>
-                <a:latin typeface="Calibri"/>
-              </a:rPr>
-              <a:t>Detection accuracy</a:t>
-            </a:r>
-          </a:p>
-        </p:txBody>
-      </p:sp>
-      <p:sp>
-        <p:nvSpPr>
-          <p:cNvPr id="115" name="c115"/>
-          <p:cNvSpPr txBox="1"/>
-          <p:nvPr/>
-        </p:nvSpPr>
-        <p:spPr>
-          <a:xfrm>
-            <a:off x="4676775" y="3924300"/>
-            <a:ext cx="2857500" cy="1047750"/>
-          </a:xfrm>
-          <a:prstGeom prst="rect">
-            <a:avLst/>
-          </a:prstGeom>
-          <a:noFill/>
-        </p:spPr>
-        <p:txBody>
-          <a:bodyPr wrap="square" anchor="t" rtlCol="0">
-            <a:normAutofit/>
-          </a:bodyPr>
-          <a:lstStyle/>
-          <a:p>
-            <a:pPr algn="l"/>
-            <a:r>
-              <a:rPr lang="en-US" sz="1100" dirty="0">
-                <a:solidFill>
-                  <a:srgbClr val="5B6B62"/>
-                </a:solidFill>
-                <a:latin typeface="Calibri"/>
-              </a:rPr>
-              <a:t>Weed/disease precision &amp; recall; dosing placement (cm).</a:t>
-            </a:r>
-          </a:p>
-        </p:txBody>
-      </p:sp>
-      <p:sp>
-        <p:nvSpPr>
-          <p:cNvPr id="120" name="s120"/>
-          <p:cNvSpPr/>
-          <p:nvPr/>
-        </p:nvSpPr>
-        <p:spPr>
-          <a:xfrm>
-            <a:off x="7962900" y="2857500"/>
-            <a:ext cx="3381375" cy="2238375"/>
-          </a:xfrm>
-          <a:prstGeom prst="roundRect">
-            <a:avLst>
-              <a:gd name="adj" fmla="val 6000"/>
-            </a:avLst>
-          </a:prstGeom>
-          <a:solidFill>
-            <a:srgbClr val="FFFFFF"/>
-          </a:solidFill>
-          <a:ln>
-            <a:noFill/>
-          </a:ln>
-        </p:spPr>
-        <p:txBody>
-          <a:bodyPr/>
-          <a:lstStyle/>
-          <a:p/>
-        </p:txBody>
-      </p:sp>
-      <p:sp>
-        <p:nvSpPr>
-          <p:cNvPr id="121" name="s121"/>
-          <p:cNvSpPr/>
-          <p:nvPr/>
-        </p:nvSpPr>
-        <p:spPr>
-          <a:xfrm>
-            <a:off x="7962900" y="2857500"/>
-            <a:ext cx="104775" cy="2238375"/>
-          </a:xfrm>
-          <a:prstGeom prst="rect">
-            <a:avLst/>
-          </a:prstGeom>
-          <a:solidFill>
-            <a:srgbClr val="F2A03D"/>
-          </a:solidFill>
-          <a:ln>
-            <a:noFill/>
-          </a:ln>
-        </p:spPr>
-        <p:txBody>
-          <a:bodyPr/>
-          <a:lstStyle/>
-          <a:p/>
-        </p:txBody>
-      </p:sp>
-      <p:sp>
-        <p:nvSpPr>
-          <p:cNvPr id="122" name="s122"/>
-          <p:cNvSpPr/>
-          <p:nvPr/>
-        </p:nvSpPr>
-        <p:spPr>
-          <a:xfrm>
-            <a:off x="8220075" y="3114675"/>
-            <a:ext cx="561975" cy="561975"/>
-          </a:xfrm>
-          <a:prstGeom prst="roundRect">
-            <a:avLst>
-              <a:gd name="adj" fmla="val 25000"/>
-            </a:avLst>
-          </a:prstGeom>
-          <a:solidFill>
-            <a:srgbClr val="F2A03D"/>
-          </a:solidFill>
-          <a:ln>
-            <a:noFill/>
-          </a:ln>
-        </p:spPr>
-        <p:txBody>
-          <a:bodyPr/>
-          <a:lstStyle/>
-          <a:p/>
-        </p:txBody>
-      </p:sp>
-      <p:sp>
-        <p:nvSpPr>
-          <p:cNvPr id="123" name="c123"/>
-          <p:cNvSpPr txBox="1"/>
-          <p:nvPr/>
-        </p:nvSpPr>
-        <p:spPr>
-          <a:xfrm>
-            <a:off x="8220075" y="3133725"/>
-            <a:ext cx="561975" cy="561975"/>
-          </a:xfrm>
-          <a:prstGeom prst="rect">
-            <a:avLst/>
-          </a:prstGeom>
-          <a:noFill/>
-        </p:spPr>
-        <p:txBody>
-          <a:bodyPr wrap="square" anchor="ctr" rtlCol="0">
-            <a:normAutofit/>
-          </a:bodyPr>
-          <a:lstStyle/>
-          <a:p>
-            <a:pPr algn="ctr"/>
-            <a:r>
-              <a:rPr lang="en-US" sz="1400" b="1" dirty="0">
-                <a:solidFill>
-                  <a:srgbClr val="FFFFFF"/>
-                </a:solidFill>
-                <a:latin typeface="Calibri"/>
-              </a:rPr>
-              <a:t>3</a:t>
-            </a:r>
-          </a:p>
-        </p:txBody>
-      </p:sp>
-      <p:sp>
-        <p:nvSpPr>
-          <p:cNvPr id="124" name="c124"/>
-          <p:cNvSpPr txBox="1"/>
-          <p:nvPr/>
-        </p:nvSpPr>
-        <p:spPr>
-          <a:xfrm>
-            <a:off x="8934450" y="3181350"/>
-            <a:ext cx="2286000" cy="381000"/>
-          </a:xfrm>
-          <a:prstGeom prst="rect">
-            <a:avLst/>
-          </a:prstGeom>
-          <a:noFill/>
-        </p:spPr>
-        <p:txBody>
-          <a:bodyPr wrap="square" anchor="t" rtlCol="0">
-            <a:normAutofit/>
-          </a:bodyPr>
-          <a:lstStyle/>
-          <a:p>
-            <a:pPr algn="l"/>
-            <a:r>
-              <a:rPr lang="en-US" sz="1400" b="1" dirty="0">
-                <a:solidFill>
-                  <a:srgbClr val="12281C"/>
-                </a:solidFill>
-                <a:latin typeface="Calibri"/>
-              </a:rPr>
-              <a:t>Coverage &amp; economics</a:t>
-            </a:r>
-          </a:p>
-        </p:txBody>
-      </p:sp>
-      <p:sp>
-        <p:nvSpPr>
-          <p:cNvPr id="125" name="c125"/>
-          <p:cNvSpPr txBox="1"/>
-          <p:nvPr/>
-        </p:nvSpPr>
-        <p:spPr>
-          <a:xfrm>
-            <a:off x="8239125" y="3924300"/>
-            <a:ext cx="2857500" cy="1047750"/>
-          </a:xfrm>
-          <a:prstGeom prst="rect">
-            <a:avLst/>
-          </a:prstGeom>
-          <a:noFill/>
-        </p:spPr>
-        <p:txBody>
-          <a:bodyPr wrap="square" anchor="t" rtlCol="0">
-            <a:normAutofit/>
-          </a:bodyPr>
-          <a:lstStyle/>
-          <a:p>
-            <a:pPr algn="l"/>
-            <a:r>
-              <a:rPr lang="en-US" sz="1100" dirty="0">
-                <a:solidFill>
-                  <a:srgbClr val="5B6B62"/>
-                </a:solidFill>
-                <a:latin typeface="Calibri"/>
-              </a:rPr>
-              <a:t>Area covered per charge; cost saving per acre.</a:t>
+              <a:t>30–50% input reduction  ·  &gt;85% detection accuracy.</a:t>
             </a:r>
           </a:p>
         </p:txBody>
@@ -8621,7 +8284,7 @@
                 </a:solidFill>
                 <a:latin typeface="Calibri"/>
               </a:rPr>
-              <a:t>Projected from our simulation &amp; targets — to be validated in the pilot.  Basis: FAI / Soil Health Card data show India's N:P:K use is skewed vs the ideal 4:2:1, so balanced, targeted dosing is where the savings come from.</a:t>
+              <a:t>Projected from our simulation model &amp; targets — to be validated in field pilots.</a:t>
             </a:r>
           </a:p>
         </p:txBody>
@@ -9316,7 +8979,29 @@
                 </a:solidFill>
                 <a:latin typeface="Segoe UI Semibold"/>
               </a:rPr>
-              <a:t>Hardware prototype — BTS7960 drive, NPK probe, pan/tilt sprayer, LiFePO4.   (Jul–Sep 2026)</a:t>
+              <a:t>Hardware prototype</a:t>
+            </a:r>
+          </a:p>
+          <a:p>
+            <a:pPr algn="l">
+              <a:lnSpc>
+                <a:spcPct val="105000"/>
+              </a:lnSpc>
+              <a:spcBef>
+                <a:spcPts val="0"/>
+              </a:spcBef>
+              <a:spcAft>
+                <a:spcPts val="0"/>
+              </a:spcAft>
+            </a:pPr>
+            <a:r>
+              <a:rPr sz="1100" b="0" i="0">
+                <a:solidFill>
+                  <a:srgbClr val="5B6B62"/>
+                </a:solidFill>
+                <a:latin typeface="Calibri"/>
+              </a:rPr>
+              <a:t>BTS7960 drive, NPK probe, pan/tilt sprayer, LiFePO4 — ~3 months</a:t>
             </a:r>
           </a:p>
         </p:txBody>
@@ -9502,7 +9187,29 @@
                 </a:solidFill>
                 <a:latin typeface="Segoe UI Semibold"/>
               </a:rPr>
-              <a:t>Pilot on 5–10 farms — measure input savings, accuracy &amp; uptime.   (Oct–Nov 2026)</a:t>
+              <a:t>Pilot on 5–10 farms</a:t>
+            </a:r>
+          </a:p>
+          <a:p>
+            <a:pPr algn="l">
+              <a:lnSpc>
+                <a:spcPct val="105000"/>
+              </a:lnSpc>
+              <a:spcBef>
+                <a:spcPts val="0"/>
+              </a:spcBef>
+              <a:spcAft>
+                <a:spcPts val="0"/>
+              </a:spcAft>
+            </a:pPr>
+            <a:r>
+              <a:rPr sz="1100" b="0" i="0">
+                <a:solidFill>
+                  <a:srgbClr val="5B6B62"/>
+                </a:solidFill>
+                <a:latin typeface="Calibri"/>
+              </a:rPr>
+              <a:t>measure input savings, accuracy &amp; uptime</a:t>
             </a:r>
           </a:p>
         </p:txBody>
@@ -9688,7 +9395,29 @@
                 </a:solidFill>
                 <a:latin typeface="Segoe UI Semibold"/>
               </a:rPr>
-              <a:t>Harden from field data — tune dosing + AI; seal for dust &amp; 40–45 °C heat.   (Dec 2026)</a:t>
+              <a:t>Harden from field data</a:t>
+            </a:r>
+          </a:p>
+          <a:p>
+            <a:pPr algn="l">
+              <a:lnSpc>
+                <a:spcPct val="105000"/>
+              </a:lnSpc>
+              <a:spcBef>
+                <a:spcPts val="0"/>
+              </a:spcBef>
+              <a:spcAft>
+                <a:spcPts val="0"/>
+              </a:spcAft>
+            </a:pPr>
+            <a:r>
+              <a:rPr sz="1100" b="0" i="0">
+                <a:solidFill>
+                  <a:srgbClr val="5B6B62"/>
+                </a:solidFill>
+                <a:latin typeface="Calibri"/>
+              </a:rPr>
+              <a:t>tune dosing + AI; seal for dust &amp; 40–45 °C heat</a:t>
             </a:r>
           </a:p>
         </p:txBody>
@@ -9874,7 +9603,29 @@
                 </a:solidFill>
                 <a:latin typeface="Segoe UI Semibold"/>
               </a:rPr>
-              <a:t>FPO / CHC roll-out — SMAM / AIF support → Rover-as-a-Service + data.   (2027 onwards)</a:t>
+              <a:t>FPO / CHC roll-out</a:t>
+            </a:r>
+          </a:p>
+          <a:p>
+            <a:pPr algn="l">
+              <a:lnSpc>
+                <a:spcPct val="105000"/>
+              </a:lnSpc>
+              <a:spcBef>
+                <a:spcPts val="0"/>
+              </a:spcBef>
+              <a:spcAft>
+                <a:spcPts val="0"/>
+              </a:spcAft>
+            </a:pPr>
+            <a:r>
+              <a:rPr sz="1100" b="0" i="0">
+                <a:solidFill>
+                  <a:srgbClr val="5B6B62"/>
+                </a:solidFill>
+                <a:latin typeface="Calibri"/>
+              </a:rPr>
+              <a:t>SMAM/AIF support → Rover-as-a-Service + data subscription</a:t>
             </a:r>
           </a:p>
         </p:txBody>
@@ -12994,6 +12745,51 @@
       </p:sp>
       <p:sp>
         <p:nvSpPr>
+          <p:cNvPr id="11" name="TextBox 10"/>
+          <p:cNvSpPr txBox="1"/>
+          <p:nvPr/>
+        </p:nvSpPr>
+        <p:spPr>
+          <a:xfrm>
+            <a:off x="841248" y="3840480"/>
+            <a:ext cx="10241280" cy="365760"/>
+          </a:xfrm>
+          <a:prstGeom prst="rect">
+            <a:avLst/>
+          </a:prstGeom>
+          <a:noFill/>
+        </p:spPr>
+        <p:txBody>
+          <a:bodyPr wrap="square" anchor="t" lIns="0" rIns="0" tIns="0" bIns="0">
+            <a:spAutoFit/>
+          </a:bodyPr>
+          <a:lstStyle/>
+          <a:p>
+            <a:pPr algn="l">
+              <a:lnSpc>
+                <a:spcPct val="108000"/>
+              </a:lnSpc>
+              <a:spcBef>
+                <a:spcPts val="0"/>
+              </a:spcBef>
+              <a:spcAft>
+                <a:spcPts val="0"/>
+              </a:spcAft>
+            </a:pPr>
+            <a:r>
+              <a:rPr sz="1300" b="1" i="0">
+                <a:solidFill>
+                  <a:srgbClr val="F2A03D"/>
+                </a:solidFill>
+                <a:latin typeface="Segoe UI Semibold"/>
+              </a:rPr>
+              <a:t>OUR ASK</a:t>
+            </a:r>
+          </a:p>
+        </p:txBody>
+      </p:sp>
+      <p:sp>
+        <p:nvSpPr>
           <p:cNvPr id="12" name="TextBox 11"/>
           <p:cNvSpPr txBox="1"/>
           <p:nvPr/>
@@ -13029,7 +12825,62 @@
                 </a:solidFill>
                 <a:latin typeface="Segoe UI Semibold"/>
               </a:rPr>
-              <a:t>Lower inputs · healthier soil · higher income — precision farming for every small farm.</a:t>
+              <a:t>▸  </a:t>
+            </a:r>
+            <a:r>
+              <a:rPr sz="1400" b="1">
+                <a:solidFill>
+                  <a:srgbClr val="EAF3EA"/>
+                </a:solidFill>
+                <a:latin typeface="Calibri"/>
+              </a:rPr>
+              <a:t>Mentorship &amp; a pilot</a:t>
+            </a:r>
+            <a:r>
+              <a:rPr sz="1250" b="0">
+                <a:solidFill>
+                  <a:srgbClr val="5B6B62"/>
+                </a:solidFill>
+                <a:latin typeface="Calibri"/>
+              </a:rPr>
+              <a:t>  —  field access via an FPO / Custom Hiring Centre</a:t>
+            </a:r>
+          </a:p>
+          <a:p>
+            <a:pPr>
+              <a:lnSpc>
+                <a:spcPct val="106000"/>
+              </a:lnSpc>
+              <a:spcAft>
+                <a:spcPts val="900"/>
+              </a:spcAft>
+            </a:pPr>
+            <a:r>
+              <a:rPr sz="1400" b="1">
+                <a:solidFill>
+                  <a:srgbClr val="6FBF44"/>
+                </a:solidFill>
+                <a:latin typeface="Segoe UI Semibold"/>
+              </a:rPr>
+              <a:t>▸  </a:t>
+            </a:r>
+            <a:r>
+              <a:rPr sz="1400" b="1">
+                <a:solidFill>
+                  <a:srgbClr val="EAF3EA"/>
+                </a:solidFill>
+                <a:latin typeface="Calibri"/>
+              </a:rPr>
+              <a:t>Seed support</a:t>
+            </a:r>
+            <a:r>
+              <a:rPr sz="1250" b="0">
+                <a:solidFill>
+                  <a:srgbClr val="5B6B62"/>
+                </a:solidFill>
+                <a:latin typeface="Calibri"/>
+              </a:rPr>
+              <a:t>  —  to build the hardware prototype and run the first pilots</a:t>
             </a:r>
           </a:p>
         </p:txBody>
@@ -15373,7 +15224,7 @@
                 </a:solidFill>
                 <a:latin typeface="Calibri"/>
               </a:rPr>
-              <a:t>Fertiliser and water are applied blindly — with no feedback on what each plant actually needs — so inputs are wasted and the soil is degraded.</a:t>
+              <a:t>India's small farms can't use big machinery — and fertilise blind. That wastes money and degrades soil.</a:t>
             </a:r>
           </a:p>
         </p:txBody>
@@ -15652,7 +15503,29 @@
                 </a:solidFill>
                 <a:latin typeface="Calibri"/>
               </a:rPr>
-              <a:t>≈86% of holdings are under 2 ha — too small for tractors.</a:t>
+              <a:t>≈86% of India's holdings are under 2 ha</a:t>
+            </a:r>
+          </a:p>
+          <a:p>
+            <a:pPr algn="l">
+              <a:lnSpc>
+                <a:spcPct val="106000"/>
+              </a:lnSpc>
+              <a:spcBef>
+                <a:spcPts val="0"/>
+              </a:spcBef>
+              <a:spcAft>
+                <a:spcPts val="400"/>
+              </a:spcAft>
+            </a:pPr>
+            <a:r>
+              <a:rPr sz="1200" b="0" i="0">
+                <a:solidFill>
+                  <a:srgbClr val="5B6B62"/>
+                </a:solidFill>
+                <a:latin typeface="Calibri"/>
+              </a:rPr>
+              <a:t>(Agriculture Census 2015–16).</a:t>
             </a:r>
           </a:p>
         </p:txBody>
@@ -15931,7 +15804,29 @@
                 </a:solidFill>
                 <a:latin typeface="Calibri"/>
               </a:rPr>
-              <a:t>No feedback loop to sense soil NPK or dose per plant.</a:t>
+              <a:t>No affordable way to sense soil NPK or</a:t>
+            </a:r>
+          </a:p>
+          <a:p>
+            <a:pPr algn="l">
+              <a:lnSpc>
+                <a:spcPct val="106000"/>
+              </a:lnSpc>
+              <a:spcBef>
+                <a:spcPts val="0"/>
+              </a:spcBef>
+              <a:spcAft>
+                <a:spcPts val="400"/>
+              </a:spcAft>
+            </a:pPr>
+            <a:r>
+              <a:rPr sz="1200" b="0" i="0">
+                <a:solidFill>
+                  <a:srgbClr val="5B6B62"/>
+                </a:solidFill>
+                <a:latin typeface="Calibri"/>
+              </a:rPr>
+              <a:t>dose per plant.</a:t>
             </a:r>
           </a:p>
         </p:txBody>
@@ -16210,7 +16105,29 @@
                 </a:solidFill>
                 <a:latin typeface="Calibri"/>
               </a:rPr>
-              <a:t>Blanket urea over-application wastes money and degrades soil.</a:t>
+              <a:t>Excess urea wastes money and</a:t>
+            </a:r>
+          </a:p>
+          <a:p>
+            <a:pPr algn="l">
+              <a:lnSpc>
+                <a:spcPct val="106000"/>
+              </a:lnSpc>
+              <a:spcBef>
+                <a:spcPts val="0"/>
+              </a:spcBef>
+              <a:spcAft>
+                <a:spcPts val="400"/>
+              </a:spcAft>
+            </a:pPr>
+            <a:r>
+              <a:rPr sz="1200" b="0" i="0">
+                <a:solidFill>
+                  <a:srgbClr val="5B6B62"/>
+                </a:solidFill>
+                <a:latin typeface="Calibri"/>
+              </a:rPr>
+              <a:t>degrades the soil.</a:t>
             </a:r>
           </a:p>
         </p:txBody>
@@ -16489,7 +16406,119 @@
                 </a:solidFill>
                 <a:latin typeface="Calibri"/>
               </a:rPr>
-              <a:t>Soil-test labs take 2–3 weeks, so guesswork wins.</a:t>
+              <a:t>Lab tests take 2–3 weeks — so old</a:t>
+            </a:r>
+          </a:p>
+          <a:p>
+            <a:pPr algn="l">
+              <a:lnSpc>
+                <a:spcPct val="106000"/>
+              </a:lnSpc>
+              <a:spcBef>
+                <a:spcPts val="0"/>
+              </a:spcBef>
+              <a:spcAft>
+                <a:spcPts val="400"/>
+              </a:spcAft>
+            </a:pPr>
+            <a:r>
+              <a:rPr sz="1200" b="0" i="0">
+                <a:solidFill>
+                  <a:srgbClr val="5B6B62"/>
+                </a:solidFill>
+                <a:latin typeface="Calibri"/>
+              </a:rPr>
+              <a:t>habits win.</a:t>
+            </a:r>
+          </a:p>
+        </p:txBody>
+      </p:sp>
+      <p:sp>
+        <p:nvSpPr>
+          <p:cNvPr id="37" name="Rounded Rectangle 36"/>
+          <p:cNvSpPr/>
+          <p:nvPr/>
+        </p:nvSpPr>
+        <p:spPr>
+          <a:xfrm>
+            <a:off x="841248" y="5596128"/>
+            <a:ext cx="10509199" cy="603504"/>
+          </a:xfrm>
+          <a:prstGeom prst="roundRect">
+            <a:avLst>
+              <a:gd name="adj" fmla="val 40000"/>
+            </a:avLst>
+          </a:prstGeom>
+          <a:solidFill>
+            <a:srgbClr val="E7F3EC"/>
+          </a:solidFill>
+          <a:ln>
+            <a:noFill/>
+          </a:ln>
+          <a:effectLst/>
+        </p:spPr>
+        <p:style>
+          <a:lnRef idx="1">
+            <a:schemeClr val="accent1"/>
+          </a:lnRef>
+          <a:fillRef idx="3">
+            <a:schemeClr val="accent1"/>
+          </a:fillRef>
+          <a:effectRef idx="2">
+            <a:schemeClr val="accent1"/>
+          </a:effectRef>
+          <a:fontRef idx="minor">
+            <a:schemeClr val="lt1"/>
+          </a:fontRef>
+        </p:style>
+        <p:txBody>
+          <a:bodyPr rtlCol="0" anchor="ctr"/>
+          <a:lstStyle/>
+          <a:p>
+            <a:pPr algn="ctr"/>
+          </a:p>
+        </p:txBody>
+      </p:sp>
+      <p:sp>
+        <p:nvSpPr>
+          <p:cNvPr id="38" name="TextBox 37"/>
+          <p:cNvSpPr txBox="1"/>
+          <p:nvPr/>
+        </p:nvSpPr>
+        <p:spPr>
+          <a:xfrm>
+            <a:off x="1115568" y="5596128"/>
+            <a:ext cx="9960559" cy="603504"/>
+          </a:xfrm>
+          <a:prstGeom prst="rect">
+            <a:avLst/>
+          </a:prstGeom>
+          <a:noFill/>
+        </p:spPr>
+        <p:txBody>
+          <a:bodyPr wrap="square" anchor="ctr" lIns="0" rIns="0" tIns="0" bIns="0">
+            <a:spAutoFit/>
+          </a:bodyPr>
+          <a:lstStyle/>
+          <a:p>
+            <a:pPr algn="ctr"/>
+            <a:r>
+              <a:rPr sz="1350" b="1">
+                <a:solidFill>
+                  <a:srgbClr val="1F9254"/>
+                </a:solidFill>
+                <a:latin typeface="Segoe UI Semibold"/>
+              </a:rPr>
+              <a:t>Validated in the field:  </a:t>
+            </a:r>
+            <a:r>
+              <a:rPr sz="1250" b="0">
+                <a:solidFill>
+                  <a:srgbClr val="12281C"/>
+                </a:solidFill>
+                <a:latin typeface="Calibri"/>
+              </a:rPr>
+              <a:t>talks with local farmers &amp; input dealers confirm uniform hand-broadcasting and guesswork dosing is the norm.</a:t>
             </a:r>
           </a:p>
         </p:txBody>
@@ -19054,7 +19083,7 @@
                 </a:solidFill>
                 <a:latin typeface="Segoe UI Semibold"/>
               </a:rPr>
-              <a:t>One autonomous field rover</a:t>
+              <a:t>One low-cost autonomous rover</a:t>
             </a:r>
           </a:p>
         </p:txBody>
@@ -19334,7 +19363,7 @@
         <p:spPr>
           <a:xfrm>
             <a:off x="841248" y="1664208"/>
-            <a:ext cx="10509199" cy="647700"/>
+            <a:ext cx="10509199" cy="502920"/>
           </a:xfrm>
           <a:prstGeom prst="rect">
             <a:avLst/>
@@ -19342,8 +19371,8 @@
           <a:noFill/>
         </p:spPr>
         <p:txBody>
-          <a:bodyPr wrap="square" rtlCol="0">
-            <a:normAutofit/>
+          <a:bodyPr wrap="square" anchor="t" lIns="0" rIns="0" tIns="0" bIns="0">
+            <a:spAutoFit/>
           </a:bodyPr>
           <a:lstStyle/>
           <a:p>
@@ -19365,7 +19394,7 @@
                 </a:solidFill>
                 <a:latin typeface="Calibri"/>
               </a:rPr>
-              <a:t>An autonomous rover that senses each plant's soil (N-P-K, pH, moisture), uses AI vision (YOLOv8n on an edge TPU) to detect weeds and disease, then doses and sprays precisely — closing the sense-decide-act loop.</a:t>
+              <a:t>AgriRover senses, decides and acts per plant — precision farming at a fraction of big-ag machinery cost.</a:t>
             </a:r>
           </a:p>
         </p:txBody>
@@ -19644,7 +19673,51 @@
                 </a:solidFill>
                 <a:latin typeface="Calibri"/>
               </a:rPr>
-              <a:t>Soil probe: N·P·K, pH, EC &amp; moisture (RS485)</a:t>
+              <a:t>7-in-1 NPK probe</a:t>
+            </a:r>
+          </a:p>
+          <a:p>
+            <a:pPr algn="l">
+              <a:lnSpc>
+                <a:spcPct val="106000"/>
+              </a:lnSpc>
+              <a:spcBef>
+                <a:spcPts val="0"/>
+              </a:spcBef>
+              <a:spcAft>
+                <a:spcPts val="400"/>
+              </a:spcAft>
+            </a:pPr>
+            <a:r>
+              <a:rPr sz="1250" b="0" i="0">
+                <a:solidFill>
+                  <a:srgbClr val="5B6B62"/>
+                </a:solidFill>
+                <a:latin typeface="Calibri"/>
+              </a:rPr>
+              <a:t>moisture · TDS · pH</a:t>
+            </a:r>
+          </a:p>
+          <a:p>
+            <a:pPr algn="l">
+              <a:lnSpc>
+                <a:spcPct val="106000"/>
+              </a:lnSpc>
+              <a:spcBef>
+                <a:spcPts val="0"/>
+              </a:spcBef>
+              <a:spcAft>
+                <a:spcPts val="400"/>
+              </a:spcAft>
+            </a:pPr>
+            <a:r>
+              <a:rPr sz="1250" b="0" i="0">
+                <a:solidFill>
+                  <a:srgbClr val="5B6B62"/>
+                </a:solidFill>
+                <a:latin typeface="Calibri"/>
+              </a:rPr>
+              <a:t>GPS + IMU + encoders</a:t>
             </a:r>
           </a:p>
         </p:txBody>
@@ -19923,7 +19996,51 @@
                 </a:solidFill>
                 <a:latin typeface="Calibri"/>
               </a:rPr>
-              <a:t>AI vision: weed, disease &amp; obstacle (YOLOv8n)</a:t>
+              <a:t>YOLOv8n vision</a:t>
+            </a:r>
+          </a:p>
+          <a:p>
+            <a:pPr algn="l">
+              <a:lnSpc>
+                <a:spcPct val="106000"/>
+              </a:lnSpc>
+              <a:spcBef>
+                <a:spcPts val="0"/>
+              </a:spcBef>
+              <a:spcAft>
+                <a:spcPts val="400"/>
+              </a:spcAft>
+            </a:pPr>
+            <a:r>
+              <a:rPr sz="1250" b="0" i="0">
+                <a:solidFill>
+                  <a:srgbClr val="5B6B62"/>
+                </a:solidFill>
+                <a:latin typeface="Calibri"/>
+              </a:rPr>
+              <a:t>weed · disease</a:t>
+            </a:r>
+          </a:p>
+          <a:p>
+            <a:pPr algn="l">
+              <a:lnSpc>
+                <a:spcPct val="106000"/>
+              </a:lnSpc>
+              <a:spcBef>
+                <a:spcPts val="0"/>
+              </a:spcBef>
+              <a:spcAft>
+                <a:spcPts val="400"/>
+              </a:spcAft>
+            </a:pPr>
+            <a:r>
+              <a:rPr sz="1250" b="0" i="0">
+                <a:solidFill>
+                  <a:srgbClr val="5B6B62"/>
+                </a:solidFill>
+                <a:latin typeface="Calibri"/>
+              </a:rPr>
+              <a:t>obstacle detection</a:t>
             </a:r>
           </a:p>
         </p:txBody>
@@ -20202,7 +20319,51 @@
                 </a:solidFill>
                 <a:latin typeface="Calibri"/>
               </a:rPr>
-              <a:t>Acts: micro-dose, spot-spray, cut &amp; seed</a:t>
+              <a:t>micro-dosing</a:t>
+            </a:r>
+          </a:p>
+          <a:p>
+            <a:pPr algn="l">
+              <a:lnSpc>
+                <a:spcPct val="106000"/>
+              </a:lnSpc>
+              <a:spcBef>
+                <a:spcPts val="0"/>
+              </a:spcBef>
+              <a:spcAft>
+                <a:spcPts val="400"/>
+              </a:spcAft>
+            </a:pPr>
+            <a:r>
+              <a:rPr sz="1250" b="0" i="0">
+                <a:solidFill>
+                  <a:srgbClr val="5B6B62"/>
+                </a:solidFill>
+                <a:latin typeface="Calibri"/>
+              </a:rPr>
+              <a:t>aimed spot-spray</a:t>
+            </a:r>
+          </a:p>
+          <a:p>
+            <a:pPr algn="l">
+              <a:lnSpc>
+                <a:spcPct val="106000"/>
+              </a:lnSpc>
+              <a:spcBef>
+                <a:spcPts val="0"/>
+              </a:spcBef>
+              <a:spcAft>
+                <a:spcPts val="400"/>
+              </a:spcAft>
+            </a:pPr>
+            <a:r>
+              <a:rPr sz="1250" b="0" i="0">
+                <a:solidFill>
+                  <a:srgbClr val="5B6B62"/>
+                </a:solidFill>
+                <a:latin typeface="Calibri"/>
+              </a:rPr>
+              <a:t>cutter · seeder · weeder</a:t>
             </a:r>
           </a:p>
         </p:txBody>
@@ -20481,7 +20642,51 @@
                 </a:solidFill>
                 <a:latin typeface="Calibri"/>
               </a:rPr>
-              <a:t>Learns: geo-tagged logs → prescription maps</a:t>
+              <a:t>geo-tagged logs</a:t>
+            </a:r>
+          </a:p>
+          <a:p>
+            <a:pPr algn="l">
+              <a:lnSpc>
+                <a:spcPct val="106000"/>
+              </a:lnSpc>
+              <a:spcBef>
+                <a:spcPts val="0"/>
+              </a:spcBef>
+              <a:spcAft>
+                <a:spcPts val="400"/>
+              </a:spcAft>
+            </a:pPr>
+            <a:r>
+              <a:rPr sz="1250" b="0" i="0">
+                <a:solidFill>
+                  <a:srgbClr val="5B6B62"/>
+                </a:solidFill>
+                <a:latin typeface="Calibri"/>
+              </a:rPr>
+              <a:t>prescription maps</a:t>
+            </a:r>
+          </a:p>
+          <a:p>
+            <a:pPr algn="l">
+              <a:lnSpc>
+                <a:spcPct val="106000"/>
+              </a:lnSpc>
+              <a:spcBef>
+                <a:spcPts val="0"/>
+              </a:spcBef>
+              <a:spcAft>
+                <a:spcPts val="400"/>
+              </a:spcAft>
+            </a:pPr>
+            <a:r>
+              <a:rPr sz="1250" b="0" i="0">
+                <a:solidFill>
+                  <a:srgbClr val="5B6B62"/>
+                </a:solidFill>
+                <a:latin typeface="Calibri"/>
+              </a:rPr>
+              <a:t>dashboard + alerts</a:t>
             </a:r>
           </a:p>
         </p:txBody>
@@ -20562,7 +20767,16 @@
                 </a:solidFill>
                 <a:latin typeface="Segoe UI Semibold"/>
               </a:rPr>
-              <a:t>Why it's different: the only autonomous, per-plant solution that also senses the soil.</a:t>
+              <a:t>Why it's different:  </a:t>
+            </a:r>
+            <a:r>
+              <a:rPr sz="1250" b="0">
+                <a:solidFill>
+                  <a:srgbClr val="12281C"/>
+                </a:solidFill>
+                <a:latin typeface="Calibri"/>
+              </a:rPr>
+              <a:t>the only affordable, autonomous, per-plant solution purpose-built for India's small farms.</a:t>
             </a:r>
           </a:p>
         </p:txBody>
@@ -22601,7 +22815,7 @@
               </a:spcAft>
             </a:pPr>
             <a:r>
-              <a:rPr sz="1600" b="0" i="1">
+              <a:rPr sz="1050" b="0" i="1">
                 <a:solidFill>
                   <a:srgbClr val="5B6B62"/>
                 </a:solidFill>
@@ -24578,7 +24792,25 @@
                 </a:solidFill>
                 <a:latin typeface="Segoe UI Semibold"/>
               </a:rPr>
-              <a:t>Sequential micro-dosing — pre-soak, probe, dose, retract (drive frozen while dosing).</a:t>
+              <a:t>▸  </a:t>
+            </a:r>
+            <a:r>
+              <a:rPr sz="1400" b="1">
+                <a:solidFill>
+                  <a:srgbClr val="12281C"/>
+                </a:solidFill>
+                <a:latin typeface="Calibri"/>
+              </a:rPr>
+              <a:t>Sequential micro-dosing</a:t>
+            </a:r>
+            <a:r>
+              <a:rPr sz="1250" b="0">
+                <a:solidFill>
+                  <a:srgbClr val="5B6B62"/>
+                </a:solidFill>
+                <a:latin typeface="Calibri"/>
+              </a:rPr>
+              <a:t>  —  pre-soak → probe → dose → retract; drive frozen while dosing</a:t>
             </a:r>
           </a:p>
           <a:p>
@@ -24597,7 +24829,25 @@
                 </a:solidFill>
                 <a:latin typeface="Segoe UI Semibold"/>
               </a:rPr>
-              <a:t>Vision-aimed spot-spray — a pan/tilt nozzle targets each detected weed.</a:t>
+              <a:t>▸  </a:t>
+            </a:r>
+            <a:r>
+              <a:rPr sz="1400" b="1">
+                <a:solidFill>
+                  <a:srgbClr val="12281C"/>
+                </a:solidFill>
+                <a:latin typeface="Calibri"/>
+              </a:rPr>
+              <a:t>Vision-aimed spot-spray</a:t>
+            </a:r>
+            <a:r>
+              <a:rPr sz="1250" b="0">
+                <a:solidFill>
+                  <a:srgbClr val="5B6B62"/>
+                </a:solidFill>
+                <a:latin typeface="Calibri"/>
+              </a:rPr>
+              <a:t>  —  pan/tilt nozzle targets each detected weed (FC-01)</a:t>
             </a:r>
           </a:p>
           <a:p>
@@ -24616,7 +24866,25 @@
                 </a:solidFill>
                 <a:latin typeface="Segoe UI Semibold"/>
               </a:rPr>
-              <a:t>Autonomous snake-route — GPS + SBAS + EKF fusion for sub-metre coverage.</a:t>
+              <a:t>▸  </a:t>
+            </a:r>
+            <a:r>
+              <a:rPr sz="1400" b="1">
+                <a:solidFill>
+                  <a:srgbClr val="12281C"/>
+                </a:solidFill>
+                <a:latin typeface="Calibri"/>
+              </a:rPr>
+              <a:t>Autonomous snake-route</a:t>
+            </a:r>
+            <a:r>
+              <a:rPr sz="1250" b="0">
+                <a:solidFill>
+                  <a:srgbClr val="5B6B62"/>
+                </a:solidFill>
+                <a:latin typeface="Calibri"/>
+              </a:rPr>
+              <a:t>  —  GPS + SBAS + EKF fusion → sub-meter coverage</a:t>
             </a:r>
           </a:p>
           <a:p>
@@ -24635,7 +24903,25 @@
                 </a:solidFill>
                 <a:latin typeface="Segoe UI Semibold"/>
               </a:rPr>
-              <a:t>Closed-loop velocity PID — straight rows and repeatable spacing.</a:t>
+              <a:t>▸  </a:t>
+            </a:r>
+            <a:r>
+              <a:rPr sz="1400" b="1">
+                <a:solidFill>
+                  <a:srgbClr val="12281C"/>
+                </a:solidFill>
+                <a:latin typeface="Calibri"/>
+              </a:rPr>
+              <a:t>Closed-loop velocity PID</a:t>
+            </a:r>
+            <a:r>
+              <a:rPr sz="1250" b="0">
+                <a:solidFill>
+                  <a:srgbClr val="5B6B62"/>
+                </a:solidFill>
+                <a:latin typeface="Calibri"/>
+              </a:rPr>
+              <a:t>  —  encoder feedback → straight rows, repeatable spacing</a:t>
             </a:r>
           </a:p>
           <a:p>
@@ -24654,7 +24940,25 @@
                 </a:solidFill>
                 <a:latin typeface="Segoe UI Semibold"/>
               </a:rPr>
-              <a:t>Fail-safe by design — E-stop, dead-man heartbeat, thermal guardian, stall stop.</a:t>
+              <a:t>▸  </a:t>
+            </a:r>
+            <a:r>
+              <a:rPr sz="1400" b="1">
+                <a:solidFill>
+                  <a:srgbClr val="12281C"/>
+                </a:solidFill>
+                <a:latin typeface="Calibri"/>
+              </a:rPr>
+              <a:t>Fail-safe by design</a:t>
+            </a:r>
+            <a:r>
+              <a:rPr sz="1250" b="0">
+                <a:solidFill>
+                  <a:srgbClr val="5B6B62"/>
+                </a:solidFill>
+                <a:latin typeface="Calibri"/>
+              </a:rPr>
+              <a:t>  —  E-stop, dead-man heartbeat, thermal guardian, stall stop</a:t>
             </a:r>
           </a:p>
         </p:txBody>

</xml_diff>